<commit_message>
Deck: add five-seed reproducibility result
Co-Authored-By: Claude Opus 5.5 <noreply@anthropic.com>
Claude-Session: https://claude.ai/code/session_015MxpDjobAG7agz1rRFFe5k
</commit_message>
<xml_diff>
--- a/presentation/BCI_Group18_Review.pptx
+++ b/presentation/BCI_Group18_Review.pptx
@@ -123,13 +123,13 @@
   <p:extLst>
     <p:ext uri="{521415D9-36F7-43E2-AB2F-B90AF26B5E84}">
       <p14:sectionLst xmlns:p14="http://schemas.microsoft.com/office/powerpoint/2010/main">
-        <p14:section name="Introduction" id="{ca836cf0-7804-3b16-16db-ba3c39e356a3}">
+        <p14:section name="Introduction" id="{95012c85-d897-bd84-7de4-2a267b81c953}">
           <p14:sldIdLst>
             <p14:sldId id="256"/>
             <p14:sldId id="257"/>
           </p14:sldIdLst>
         </p14:section>
-        <p14:section name="Data and method" id="{a45abdb8-3313-a63c-e24c-0a98cd58e779}">
+        <p14:section name="Data and method" id="{6fcc9166-e9c3-d4ef-6b9c-068ab51a1adf}">
           <p14:sldIdLst>
             <p14:sldId id="258"/>
             <p14:sldId id="259"/>
@@ -140,7 +140,7 @@
             <p14:sldId id="264"/>
           </p14:sldIdLst>
         </p14:section>
-        <p14:section name="Results" id="{4607aecd-0f74-c6a6-5d49-0f505810f3e0}">
+        <p14:section name="Results" id="{ff6443d2-3414-712e-6d09-762a060929b7}">
           <p14:sldIdLst>
             <p14:sldId id="265"/>
             <p14:sldId id="266"/>
@@ -148,13 +148,13 @@
             <p14:sldId id="268"/>
           </p14:sldIdLst>
         </p14:section>
-        <p14:section name="Validity" id="{a2423fd0-5c10-6c1c-f6e1-a0465692deb3}">
+        <p14:section name="Validity" id="{ef6f07ba-c82e-1111-b1c9-2e6c39230abe}">
           <p14:sldIdLst>
             <p14:sldId id="269"/>
             <p14:sldId id="270"/>
           </p14:sldIdLst>
         </p14:section>
-        <p14:section name="Conclusion" id="{652f2f26-8bb0-c277-87c0-19fcffdeefe3}">
+        <p14:section name="Conclusion" id="{1fdd351d-d023-5e7d-315e-7256635288d7}">
           <p14:sldIdLst>
             <p14:sldId id="271"/>
             <p14:sldId id="272"/>
@@ -7317,7 +7317,7 @@
                   <a:schemeClr val="tx1"/>
                 </a:solidFill>
               </a:rPr>
-              <a:t>Same seed, two runs: 382 / 476 both times. Different seed: 384 / 476. The result does not drift upward.</a:t>
+              <a:t>Same seed twice: 382 / 476 both times. Seeds 1, 2, 3: 384, 384, 386. Mean 80.59 ± 0.35%; changes come from the seed, not from learning across runs.</a:t>
             </a:r>
             <a:endParaRPr lang="en-US" sz="1300" dirty="0"/>
           </a:p>
@@ -7905,7 +7905,7 @@
                             <a:schemeClr val="tx1"/>
                           </a:solidFill>
                         </a:rPr>
-                        <a:t>No. Fixed seed gives identical results (382/476 twice); permutation tests sit at chance; folds are split by person. Nested CV on all tasks is being completed.</a:t>
+                        <a:t>No. Same seed gives identical results (382/476 twice); other seeds give 384–386 (80.59 ± 0.35% over 5 runs); permutation tests sit at chance; folds are split by person. Nested CV on all tasks is being completed.</a:t>
                       </a:r>
                       <a:endParaRPr lang="en-US" sz="1200" dirty="0"/>
                     </a:p>

</xml_diff>

<commit_message>
Left vs right imagery: all models with and without FBCSP; update review deck
Co-Authored-By: Claude Opus 5.5 <noreply@anthropic.com>
Claude-Session: https://claude.ai/code/session_015MxpDjobAG7agz1rRFFe5k
</commit_message>
<xml_diff>
--- a/presentation/BCI_Group18_Review.pptx
+++ b/presentation/BCI_Group18_Review.pptx
@@ -22,9 +22,10 @@
     <p:sldId id="270" r:id="rId16"/>
     <p:sldId id="271" r:id="rId17"/>
     <p:sldId id="272" r:id="rId18"/>
+    <p:sldId id="273" r:id="rId19"/>
   </p:sldIdLst>
   <p:notesMasterIdLst>
-    <p:notesMasterId r:id="rId19"/>
+    <p:notesMasterId r:id="rId20"/>
   </p:notesMasterIdLst>
   <p:sldSz cx="9144000" cy="5143500"/>
   <p:notesSz cx="5143500" cy="9144000"/>
@@ -123,13 +124,13 @@
   <p:extLst>
     <p:ext uri="{521415D9-36F7-43E2-AB2F-B90AF26B5E84}">
       <p14:sectionLst xmlns:p14="http://schemas.microsoft.com/office/powerpoint/2010/main">
-        <p14:section name="Introduction" id="{95012c85-d897-bd84-7de4-2a267b81c953}">
+        <p14:section name="Introduction" id="{fdb7ffd8-df88-4115-efe6-deacc4912e98}">
           <p14:sldIdLst>
             <p14:sldId id="256"/>
             <p14:sldId id="257"/>
           </p14:sldIdLst>
         </p14:section>
-        <p14:section name="Data and method" id="{6fcc9166-e9c3-d4ef-6b9c-068ab51a1adf}">
+        <p14:section name="Data and method" id="{45748933-26a2-7bca-8ff8-a7b788badaab}">
           <p14:sldIdLst>
             <p14:sldId id="258"/>
             <p14:sldId id="259"/>
@@ -140,24 +141,25 @@
             <p14:sldId id="264"/>
           </p14:sldIdLst>
         </p14:section>
-        <p14:section name="Results" id="{ff6443d2-3414-712e-6d09-762a060929b7}">
+        <p14:section name="Results" id="{f24bd66f-d34a-a348-b846-01efa09a709f}">
           <p14:sldIdLst>
             <p14:sldId id="265"/>
             <p14:sldId id="266"/>
             <p14:sldId id="267"/>
             <p14:sldId id="268"/>
+            <p14:sldId id="269"/>
           </p14:sldIdLst>
         </p14:section>
-        <p14:section name="Validity" id="{ef6f07ba-c82e-1111-b1c9-2e6c39230abe}">
+        <p14:section name="Validity" id="{e8956725-a8e4-5562-bce5-3e8df2428635}">
           <p14:sldIdLst>
-            <p14:sldId id="269"/>
             <p14:sldId id="270"/>
+            <p14:sldId id="271"/>
           </p14:sldIdLst>
         </p14:section>
-        <p14:section name="Conclusion" id="{1fdd351d-d023-5e7d-315e-7256635288d7}">
+        <p14:section name="Conclusion" id="{21127d94-f144-b76d-56e8-3a31e0319614}">
           <p14:sldIdLst>
-            <p14:sldId id="271"/>
             <p14:sldId id="272"/>
+            <p14:sldId id="273"/>
           </p14:sldIdLst>
         </p14:section>
       </p14:sectionLst>
@@ -1282,7 +1284,7 @@
           <a:p>
             <a:r>
               <a:rPr lang="en-US" dirty="0"/>
-              <a:t>Every scaler, alignment and model is refitted inside each fold. Normalisation per recording uses no labels. Permutation tests at chance confirm the pipeline is not memorising subject identity.</a:t>
+              <a:t>Answers the guide: all eight models were run on left versus right imagery, each with and without filter-bank CSP features fitted inside each training fold. Chance is 50 percent. Ensemble 140 of 241, p = 0.007. LR or LDA with CSP 143 of 241, p = 0.002.</a:t>
             </a:r>
             <a:endParaRPr lang="en-US" dirty="0"/>
           </a:p>
@@ -1370,7 +1372,7 @@
           <a:p>
             <a:r>
               <a:rPr lang="en-US" dirty="0"/>
-              <a:t>CSP learns spatial filters for two-class variance differences. Our feature set already includes band power per channel and Riemannian covariance features, which carry the same information, so CSP is expected to add little.</a:t>
+              <a:t>Every scaler, alignment and model is refitted inside each fold. Normalisation per recording uses no labels. Permutation tests at chance confirm the pipeline is not memorising subject identity.</a:t>
             </a:r>
             <a:endParaRPr lang="en-US" dirty="0"/>
           </a:p>
@@ -1458,7 +1460,7 @@
           <a:p>
             <a:r>
               <a:rPr lang="en-US" dirty="0"/>
-              <a:t>Be honest about the multi-class results; the main contribution is a leakage-free pipeline and a strong action versus imagery result on a consumer headset.</a:t>
+              <a:t>CSP learns spatial filters for two-class variance differences. Our feature set already includes band power per channel and Riemannian covariance features, which carry the same information, so CSP is expected to add little.</a:t>
             </a:r>
             <a:endParaRPr lang="en-US" dirty="0"/>
           </a:p>
@@ -1546,7 +1548,7 @@
           <a:p>
             <a:r>
               <a:rPr lang="en-US" dirty="0"/>
-              <a:t/>
+              <a:t>Be honest about the multi-class results; the main contribution is a leakage-free pipeline and a strong action versus imagery result on a consumer headset.</a:t>
             </a:r>
             <a:endParaRPr lang="en-US" dirty="0"/>
           </a:p>
@@ -1570,6 +1572,94 @@
             <a:fld id="{F7021451-1387-4CA6-816F-3879F97B5CBC}" type="slidenum">
               <a:rPr lang="en-US"/>
               <a:t>17</a:t>
+            </a:fld>
+            <a:endParaRPr lang="en-US"/>
+          </a:p>
+        </p:txBody>
+      </p:sp>
+    </p:spTree>
+    <p:extLst>
+      <p:ext uri="{BB962C8B-B14F-4D97-AF65-F5344CB8AC3E}">
+        <p14:creationId xmlns:p14="http://schemas.microsoft.com/office/powerpoint/2010/main" val="1024086991"/>
+      </p:ext>
+    </p:extLst>
+  </p:cSld>
+  <p:clrMapOvr>
+    <a:masterClrMapping/>
+  </p:clrMapOvr>
+</p:notes>
+</file>
+
+<file path=ppt/notesSlides/notesSlide18.xml><?xml version="1.0" encoding="utf-8"?>
+<p:notes xmlns:a="http://schemas.openxmlformats.org/drawingml/2006/main" xmlns:r="http://schemas.openxmlformats.org/officeDocument/2006/relationships" xmlns:p="http://schemas.openxmlformats.org/presentationml/2006/main">
+  <p:cSld>
+    <p:spTree>
+      <p:nvGrpSpPr>
+        <p:cNvPr id="1" name=""/>
+        <p:cNvGrpSpPr/>
+        <p:nvPr/>
+      </p:nvGrpSpPr>
+      <p:grpSpPr>
+        <a:xfrm>
+          <a:off x="0" y="0"/>
+          <a:ext cx="0" cy="0"/>
+          <a:chOff x="0" y="0"/>
+          <a:chExt cx="0" cy="0"/>
+        </a:xfrm>
+      </p:grpSpPr>
+      <p:sp>
+        <p:nvSpPr>
+          <p:cNvPr id="2" name="Slide Image Placeholder 1"/>
+          <p:cNvSpPr>
+            <a:spLocks noGrp="1" noRot="1" noChangeAspect="1"/>
+          </p:cNvSpPr>
+          <p:nvPr>
+            <p:ph type="sldImg"/>
+          </p:nvPr>
+        </p:nvSpPr>
+        <p:spPr/>
+      </p:sp>
+      <p:sp>
+        <p:nvSpPr>
+          <p:cNvPr id="3" name="Notes Placeholder 2"/>
+          <p:cNvSpPr>
+            <a:spLocks noGrp="1"/>
+          </p:cNvSpPr>
+          <p:nvPr>
+            <p:ph type="body" idx="1"/>
+          </p:nvPr>
+        </p:nvSpPr>
+        <p:spPr/>
+        <p:txBody>
+          <a:bodyPr/>
+          <a:lstStyle/>
+          <a:p>
+            <a:r>
+              <a:rPr lang="en-US" dirty="0"/>
+              <a:t/>
+            </a:r>
+            <a:endParaRPr lang="en-US" dirty="0"/>
+          </a:p>
+        </p:txBody>
+      </p:sp>
+      <p:sp>
+        <p:nvSpPr>
+          <p:cNvPr id="4" name="Slide Number Placeholder 3"/>
+          <p:cNvSpPr>
+            <a:spLocks noGrp="1"/>
+          </p:cNvSpPr>
+          <p:nvPr>
+            <p:ph type="sldNum" sz="quarter" idx="10"/>
+          </p:nvPr>
+        </p:nvSpPr>
+        <p:spPr/>
+        <p:txBody>
+          <a:bodyPr/>
+          <a:lstStyle/>
+          <a:p>
+            <a:fld id="{F7021451-1387-4CA6-816F-3879F97B5CBC}" type="slidenum">
+              <a:rPr lang="en-US"/>
+              <a:t>18</a:t>
             </a:fld>
             <a:endParaRPr lang="en-US"/>
           </a:p>
@@ -6918,119 +7008,3005 @@
                   <a:schemeClr val="tx2"/>
                 </a:solidFill>
               </a:rPr>
-              <a:t>Is the accuracy real? Leakage checks</a:t>
+              <a:t>Left vs right: every model, with and without CSP</a:t>
             </a:r>
             <a:endParaRPr lang="en-US" sz="2400" dirty="0"/>
           </a:p>
         </p:txBody>
       </p:sp>
-      <p:sp>
-        <p:nvSpPr>
-          <p:cNvPr id="3" name="check Person-wise folds"/>
-          <p:cNvSpPr/>
+      <p:graphicFrame>
+        <p:nvGraphicFramePr>
+          <p:cNvPr id="15" name="Table 0"/>
+          <p:cNvGraphicFramePr>
+            <a:graphicFrameLocks noGrp="1"/>
+          </p:cNvGraphicFramePr>
+          <p:nvPr>
+            <p:extLst>
+              <p:ext uri="{D42A27DB-BD31-4B8C-83A1-F6EECF244321}">
+                <p14:modId xmlns:p14="http://schemas.microsoft.com/office/powerpoint/2010/main" val="1579011935"/>
+              </p:ext>
+            </p:extLst>
+          </p:nvPr>
+        </p:nvGraphicFramePr>
+        <p:xfrm>
+          <a:off x="457200" y="914400"/>
+          <a:ext cx="5486400" cy="914400"/>
+        </p:xfrm>
+        <a:graphic>
+          <a:graphicData uri="http://schemas.openxmlformats.org/drawingml/2006/table">
+            <a:tbl>
+              <a:tblPr/>
+              <a:tblGrid>
+                <a:gridCol w="2194560"/>
+                <a:gridCol w="822960"/>
+                <a:gridCol w="731520"/>
+                <a:gridCol w="1005840"/>
+                <a:gridCol w="731520"/>
+              </a:tblGrid>
+              <a:tr h="329184">
+                <a:tc>
+                  <a:txBody>
+                    <a:bodyPr/>
+                    <a:lstStyle/>
+                    <a:p>
+                      <a:pPr indent="0" marL="0">
+                        <a:buNone/>
+                      </a:pPr>
+                      <a:r>
+                        <a:rPr lang="en-US" sz="1200" b="1" dirty="0">
+                          <a:solidFill>
+                            <a:schemeClr val="bg1"/>
+                          </a:solidFill>
+                        </a:rPr>
+                        <a:t>Model (241 imagery trials)</a:t>
+                      </a:r>
+                      <a:endParaRPr lang="en-US" sz="1200" dirty="0"/>
+                    </a:p>
+                  </a:txBody>
+                  <a:tcPr marL="91440" marR="91440" marT="45720" marB="45720">
+                    <a:lnL w="6350" cap="flat" cmpd="sng" algn="ctr">
+                      <a:solidFill>
+                        <a:srgbClr val="D0D5DD"/>
+                      </a:solidFill>
+                      <a:prstDash val="solid"/>
+                      <a:round/>
+                      <a:headEnd type="none" w="med" len="med"/>
+                      <a:tailEnd type="none" w="med" len="med"/>
+                    </a:lnL>
+                    <a:lnR w="6350" cap="flat" cmpd="sng" algn="ctr">
+                      <a:solidFill>
+                        <a:srgbClr val="D0D5DD"/>
+                      </a:solidFill>
+                      <a:prstDash val="solid"/>
+                      <a:round/>
+                      <a:headEnd type="none" w="med" len="med"/>
+                      <a:tailEnd type="none" w="med" len="med"/>
+                    </a:lnR>
+                    <a:lnT w="6350" cap="flat" cmpd="sng" algn="ctr">
+                      <a:solidFill>
+                        <a:srgbClr val="D0D5DD"/>
+                      </a:solidFill>
+                      <a:prstDash val="solid"/>
+                      <a:round/>
+                      <a:headEnd type="none" w="med" len="med"/>
+                      <a:tailEnd type="none" w="med" len="med"/>
+                    </a:lnT>
+                    <a:lnB w="6350" cap="flat" cmpd="sng" algn="ctr">
+                      <a:solidFill>
+                        <a:srgbClr val="D0D5DD"/>
+                      </a:solidFill>
+                      <a:prstDash val="solid"/>
+                      <a:round/>
+                      <a:headEnd type="none" w="med" len="med"/>
+                      <a:tailEnd type="none" w="med" len="med"/>
+                    </a:lnB>
+                    <a:solidFill>
+                      <a:schemeClr val="tx2"/>
+                    </a:solidFill>
+                  </a:tcPr>
+                </a:tc>
+                <a:tc>
+                  <a:txBody>
+                    <a:bodyPr/>
+                    <a:lstStyle/>
+                    <a:p>
+                      <a:pPr indent="0" marL="0">
+                        <a:buNone/>
+                      </a:pPr>
+                      <a:r>
+                        <a:rPr lang="en-US" sz="1200" b="1" dirty="0">
+                          <a:solidFill>
+                            <a:schemeClr val="bg1"/>
+                          </a:solidFill>
+                        </a:rPr>
+                        <a:t>Base: correct</a:t>
+                      </a:r>
+                      <a:endParaRPr lang="en-US" sz="1200" dirty="0"/>
+                    </a:p>
+                  </a:txBody>
+                  <a:tcPr marL="91440" marR="91440" marT="45720" marB="45720">
+                    <a:lnL w="6350" cap="flat" cmpd="sng" algn="ctr">
+                      <a:solidFill>
+                        <a:srgbClr val="D0D5DD"/>
+                      </a:solidFill>
+                      <a:prstDash val="solid"/>
+                      <a:round/>
+                      <a:headEnd type="none" w="med" len="med"/>
+                      <a:tailEnd type="none" w="med" len="med"/>
+                    </a:lnL>
+                    <a:lnR w="6350" cap="flat" cmpd="sng" algn="ctr">
+                      <a:solidFill>
+                        <a:srgbClr val="D0D5DD"/>
+                      </a:solidFill>
+                      <a:prstDash val="solid"/>
+                      <a:round/>
+                      <a:headEnd type="none" w="med" len="med"/>
+                      <a:tailEnd type="none" w="med" len="med"/>
+                    </a:lnR>
+                    <a:lnT w="6350" cap="flat" cmpd="sng" algn="ctr">
+                      <a:solidFill>
+                        <a:srgbClr val="D0D5DD"/>
+                      </a:solidFill>
+                      <a:prstDash val="solid"/>
+                      <a:round/>
+                      <a:headEnd type="none" w="med" len="med"/>
+                      <a:tailEnd type="none" w="med" len="med"/>
+                    </a:lnT>
+                    <a:lnB w="6350" cap="flat" cmpd="sng" algn="ctr">
+                      <a:solidFill>
+                        <a:srgbClr val="D0D5DD"/>
+                      </a:solidFill>
+                      <a:prstDash val="solid"/>
+                      <a:round/>
+                      <a:headEnd type="none" w="med" len="med"/>
+                      <a:tailEnd type="none" w="med" len="med"/>
+                    </a:lnB>
+                    <a:solidFill>
+                      <a:schemeClr val="tx2"/>
+                    </a:solidFill>
+                  </a:tcPr>
+                </a:tc>
+                <a:tc>
+                  <a:txBody>
+                    <a:bodyPr/>
+                    <a:lstStyle/>
+                    <a:p>
+                      <a:pPr indent="0" marL="0">
+                        <a:buNone/>
+                      </a:pPr>
+                      <a:r>
+                        <a:rPr lang="en-US" sz="1200" b="1" dirty="0">
+                          <a:solidFill>
+                            <a:schemeClr val="bg1"/>
+                          </a:solidFill>
+                        </a:rPr>
+                        <a:t>Base %</a:t>
+                      </a:r>
+                      <a:endParaRPr lang="en-US" sz="1200" dirty="0"/>
+                    </a:p>
+                  </a:txBody>
+                  <a:tcPr marL="91440" marR="91440" marT="45720" marB="45720">
+                    <a:lnL w="6350" cap="flat" cmpd="sng" algn="ctr">
+                      <a:solidFill>
+                        <a:srgbClr val="D0D5DD"/>
+                      </a:solidFill>
+                      <a:prstDash val="solid"/>
+                      <a:round/>
+                      <a:headEnd type="none" w="med" len="med"/>
+                      <a:tailEnd type="none" w="med" len="med"/>
+                    </a:lnL>
+                    <a:lnR w="6350" cap="flat" cmpd="sng" algn="ctr">
+                      <a:solidFill>
+                        <a:srgbClr val="D0D5DD"/>
+                      </a:solidFill>
+                      <a:prstDash val="solid"/>
+                      <a:round/>
+                      <a:headEnd type="none" w="med" len="med"/>
+                      <a:tailEnd type="none" w="med" len="med"/>
+                    </a:lnR>
+                    <a:lnT w="6350" cap="flat" cmpd="sng" algn="ctr">
+                      <a:solidFill>
+                        <a:srgbClr val="D0D5DD"/>
+                      </a:solidFill>
+                      <a:prstDash val="solid"/>
+                      <a:round/>
+                      <a:headEnd type="none" w="med" len="med"/>
+                      <a:tailEnd type="none" w="med" len="med"/>
+                    </a:lnT>
+                    <a:lnB w="6350" cap="flat" cmpd="sng" algn="ctr">
+                      <a:solidFill>
+                        <a:srgbClr val="D0D5DD"/>
+                      </a:solidFill>
+                      <a:prstDash val="solid"/>
+                      <a:round/>
+                      <a:headEnd type="none" w="med" len="med"/>
+                      <a:tailEnd type="none" w="med" len="med"/>
+                    </a:lnB>
+                    <a:solidFill>
+                      <a:schemeClr val="tx2"/>
+                    </a:solidFill>
+                  </a:tcPr>
+                </a:tc>
+                <a:tc>
+                  <a:txBody>
+                    <a:bodyPr/>
+                    <a:lstStyle/>
+                    <a:p>
+                      <a:pPr indent="0" marL="0">
+                        <a:buNone/>
+                      </a:pPr>
+                      <a:r>
+                        <a:rPr lang="en-US" sz="1200" b="1" dirty="0">
+                          <a:solidFill>
+                            <a:schemeClr val="bg1"/>
+                          </a:solidFill>
+                        </a:rPr>
+                        <a:t>+ FBCSP: correct</a:t>
+                      </a:r>
+                      <a:endParaRPr lang="en-US" sz="1200" dirty="0"/>
+                    </a:p>
+                  </a:txBody>
+                  <a:tcPr marL="91440" marR="91440" marT="45720" marB="45720">
+                    <a:lnL w="6350" cap="flat" cmpd="sng" algn="ctr">
+                      <a:solidFill>
+                        <a:srgbClr val="D0D5DD"/>
+                      </a:solidFill>
+                      <a:prstDash val="solid"/>
+                      <a:round/>
+                      <a:headEnd type="none" w="med" len="med"/>
+                      <a:tailEnd type="none" w="med" len="med"/>
+                    </a:lnL>
+                    <a:lnR w="6350" cap="flat" cmpd="sng" algn="ctr">
+                      <a:solidFill>
+                        <a:srgbClr val="D0D5DD"/>
+                      </a:solidFill>
+                      <a:prstDash val="solid"/>
+                      <a:round/>
+                      <a:headEnd type="none" w="med" len="med"/>
+                      <a:tailEnd type="none" w="med" len="med"/>
+                    </a:lnR>
+                    <a:lnT w="6350" cap="flat" cmpd="sng" algn="ctr">
+                      <a:solidFill>
+                        <a:srgbClr val="D0D5DD"/>
+                      </a:solidFill>
+                      <a:prstDash val="solid"/>
+                      <a:round/>
+                      <a:headEnd type="none" w="med" len="med"/>
+                      <a:tailEnd type="none" w="med" len="med"/>
+                    </a:lnT>
+                    <a:lnB w="6350" cap="flat" cmpd="sng" algn="ctr">
+                      <a:solidFill>
+                        <a:srgbClr val="D0D5DD"/>
+                      </a:solidFill>
+                      <a:prstDash val="solid"/>
+                      <a:round/>
+                      <a:headEnd type="none" w="med" len="med"/>
+                      <a:tailEnd type="none" w="med" len="med"/>
+                    </a:lnB>
+                    <a:solidFill>
+                      <a:schemeClr val="tx2"/>
+                    </a:solidFill>
+                  </a:tcPr>
+                </a:tc>
+                <a:tc>
+                  <a:txBody>
+                    <a:bodyPr/>
+                    <a:lstStyle/>
+                    <a:p>
+                      <a:pPr indent="0" marL="0">
+                        <a:buNone/>
+                      </a:pPr>
+                      <a:r>
+                        <a:rPr lang="en-US" sz="1200" b="1" dirty="0">
+                          <a:solidFill>
+                            <a:schemeClr val="bg1"/>
+                          </a:solidFill>
+                        </a:rPr>
+                        <a:t>+ FBCSP %</a:t>
+                      </a:r>
+                      <a:endParaRPr lang="en-US" sz="1200" dirty="0"/>
+                    </a:p>
+                  </a:txBody>
+                  <a:tcPr marL="91440" marR="91440" marT="45720" marB="45720">
+                    <a:lnL w="6350" cap="flat" cmpd="sng" algn="ctr">
+                      <a:solidFill>
+                        <a:srgbClr val="D0D5DD"/>
+                      </a:solidFill>
+                      <a:prstDash val="solid"/>
+                      <a:round/>
+                      <a:headEnd type="none" w="med" len="med"/>
+                      <a:tailEnd type="none" w="med" len="med"/>
+                    </a:lnL>
+                    <a:lnR w="6350" cap="flat" cmpd="sng" algn="ctr">
+                      <a:solidFill>
+                        <a:srgbClr val="D0D5DD"/>
+                      </a:solidFill>
+                      <a:prstDash val="solid"/>
+                      <a:round/>
+                      <a:headEnd type="none" w="med" len="med"/>
+                      <a:tailEnd type="none" w="med" len="med"/>
+                    </a:lnR>
+                    <a:lnT w="6350" cap="flat" cmpd="sng" algn="ctr">
+                      <a:solidFill>
+                        <a:srgbClr val="D0D5DD"/>
+                      </a:solidFill>
+                      <a:prstDash val="solid"/>
+                      <a:round/>
+                      <a:headEnd type="none" w="med" len="med"/>
+                      <a:tailEnd type="none" w="med" len="med"/>
+                    </a:lnT>
+                    <a:lnB w="6350" cap="flat" cmpd="sng" algn="ctr">
+                      <a:solidFill>
+                        <a:srgbClr val="D0D5DD"/>
+                      </a:solidFill>
+                      <a:prstDash val="solid"/>
+                      <a:round/>
+                      <a:headEnd type="none" w="med" len="med"/>
+                      <a:tailEnd type="none" w="med" len="med"/>
+                    </a:lnB>
+                    <a:solidFill>
+                      <a:schemeClr val="tx2"/>
+                    </a:solidFill>
+                  </a:tcPr>
+                </a:tc>
+              </a:tr>
+              <a:tr h="329184">
+                <a:tc>
+                  <a:txBody>
+                    <a:bodyPr/>
+                    <a:lstStyle/>
+                    <a:p>
+                      <a:pPr indent="0" marL="0">
+                        <a:buNone/>
+                      </a:pPr>
+                      <a:r>
+                        <a:rPr lang="en-US" sz="1200" b="1" dirty="0">
+                          <a:solidFill>
+                            <a:schemeClr val="accent1"/>
+                          </a:solidFill>
+                        </a:rPr>
+                        <a:t>Ensemble (LR+LDA+ET+HGB)</a:t>
+                      </a:r>
+                      <a:endParaRPr lang="en-US" sz="1200" dirty="0"/>
+                    </a:p>
+                  </a:txBody>
+                  <a:tcPr marL="91440" marR="91440" marT="45720" marB="45720">
+                    <a:lnL w="6350" cap="flat" cmpd="sng" algn="ctr">
+                      <a:solidFill>
+                        <a:srgbClr val="D0D5DD"/>
+                      </a:solidFill>
+                      <a:prstDash val="solid"/>
+                      <a:round/>
+                      <a:headEnd type="none" w="med" len="med"/>
+                      <a:tailEnd type="none" w="med" len="med"/>
+                    </a:lnL>
+                    <a:lnR w="6350" cap="flat" cmpd="sng" algn="ctr">
+                      <a:solidFill>
+                        <a:srgbClr val="D0D5DD"/>
+                      </a:solidFill>
+                      <a:prstDash val="solid"/>
+                      <a:round/>
+                      <a:headEnd type="none" w="med" len="med"/>
+                      <a:tailEnd type="none" w="med" len="med"/>
+                    </a:lnR>
+                    <a:lnT w="6350" cap="flat" cmpd="sng" algn="ctr">
+                      <a:solidFill>
+                        <a:srgbClr val="D0D5DD"/>
+                      </a:solidFill>
+                      <a:prstDash val="solid"/>
+                      <a:round/>
+                      <a:headEnd type="none" w="med" len="med"/>
+                      <a:tailEnd type="none" w="med" len="med"/>
+                    </a:lnT>
+                    <a:lnB w="6350" cap="flat" cmpd="sng" algn="ctr">
+                      <a:solidFill>
+                        <a:srgbClr val="D0D5DD"/>
+                      </a:solidFill>
+                      <a:prstDash val="solid"/>
+                      <a:round/>
+                      <a:headEnd type="none" w="med" len="med"/>
+                      <a:tailEnd type="none" w="med" len="med"/>
+                    </a:lnB>
+                    <a:solidFill>
+                      <a:schemeClr val="accent5"/>
+                    </a:solidFill>
+                  </a:tcPr>
+                </a:tc>
+                <a:tc>
+                  <a:txBody>
+                    <a:bodyPr/>
+                    <a:lstStyle/>
+                    <a:p>
+                      <a:pPr indent="0" marL="0">
+                        <a:buNone/>
+                      </a:pPr>
+                      <a:r>
+                        <a:rPr lang="en-US" sz="1200" b="1" dirty="0">
+                          <a:solidFill>
+                            <a:schemeClr val="accent1"/>
+                          </a:solidFill>
+                        </a:rPr>
+                        <a:t>140</a:t>
+                      </a:r>
+                      <a:endParaRPr lang="en-US" sz="1200" dirty="0"/>
+                    </a:p>
+                  </a:txBody>
+                  <a:tcPr marL="91440" marR="91440" marT="45720" marB="45720">
+                    <a:lnL w="6350" cap="flat" cmpd="sng" algn="ctr">
+                      <a:solidFill>
+                        <a:srgbClr val="D0D5DD"/>
+                      </a:solidFill>
+                      <a:prstDash val="solid"/>
+                      <a:round/>
+                      <a:headEnd type="none" w="med" len="med"/>
+                      <a:tailEnd type="none" w="med" len="med"/>
+                    </a:lnL>
+                    <a:lnR w="6350" cap="flat" cmpd="sng" algn="ctr">
+                      <a:solidFill>
+                        <a:srgbClr val="D0D5DD"/>
+                      </a:solidFill>
+                      <a:prstDash val="solid"/>
+                      <a:round/>
+                      <a:headEnd type="none" w="med" len="med"/>
+                      <a:tailEnd type="none" w="med" len="med"/>
+                    </a:lnR>
+                    <a:lnT w="6350" cap="flat" cmpd="sng" algn="ctr">
+                      <a:solidFill>
+                        <a:srgbClr val="D0D5DD"/>
+                      </a:solidFill>
+                      <a:prstDash val="solid"/>
+                      <a:round/>
+                      <a:headEnd type="none" w="med" len="med"/>
+                      <a:tailEnd type="none" w="med" len="med"/>
+                    </a:lnT>
+                    <a:lnB w="6350" cap="flat" cmpd="sng" algn="ctr">
+                      <a:solidFill>
+                        <a:srgbClr val="D0D5DD"/>
+                      </a:solidFill>
+                      <a:prstDash val="solid"/>
+                      <a:round/>
+                      <a:headEnd type="none" w="med" len="med"/>
+                      <a:tailEnd type="none" w="med" len="med"/>
+                    </a:lnB>
+                    <a:solidFill>
+                      <a:schemeClr val="accent5"/>
+                    </a:solidFill>
+                  </a:tcPr>
+                </a:tc>
+                <a:tc>
+                  <a:txBody>
+                    <a:bodyPr/>
+                    <a:lstStyle/>
+                    <a:p>
+                      <a:pPr indent="0" marL="0">
+                        <a:buNone/>
+                      </a:pPr>
+                      <a:r>
+                        <a:rPr lang="en-US" sz="1200" b="1" dirty="0">
+                          <a:solidFill>
+                            <a:schemeClr val="accent1"/>
+                          </a:solidFill>
+                        </a:rPr>
+                        <a:t>58.09</a:t>
+                      </a:r>
+                      <a:endParaRPr lang="en-US" sz="1200" dirty="0"/>
+                    </a:p>
+                  </a:txBody>
+                  <a:tcPr marL="91440" marR="91440" marT="45720" marB="45720">
+                    <a:lnL w="6350" cap="flat" cmpd="sng" algn="ctr">
+                      <a:solidFill>
+                        <a:srgbClr val="D0D5DD"/>
+                      </a:solidFill>
+                      <a:prstDash val="solid"/>
+                      <a:round/>
+                      <a:headEnd type="none" w="med" len="med"/>
+                      <a:tailEnd type="none" w="med" len="med"/>
+                    </a:lnL>
+                    <a:lnR w="6350" cap="flat" cmpd="sng" algn="ctr">
+                      <a:solidFill>
+                        <a:srgbClr val="D0D5DD"/>
+                      </a:solidFill>
+                      <a:prstDash val="solid"/>
+                      <a:round/>
+                      <a:headEnd type="none" w="med" len="med"/>
+                      <a:tailEnd type="none" w="med" len="med"/>
+                    </a:lnR>
+                    <a:lnT w="6350" cap="flat" cmpd="sng" algn="ctr">
+                      <a:solidFill>
+                        <a:srgbClr val="D0D5DD"/>
+                      </a:solidFill>
+                      <a:prstDash val="solid"/>
+                      <a:round/>
+                      <a:headEnd type="none" w="med" len="med"/>
+                      <a:tailEnd type="none" w="med" len="med"/>
+                    </a:lnT>
+                    <a:lnB w="6350" cap="flat" cmpd="sng" algn="ctr">
+                      <a:solidFill>
+                        <a:srgbClr val="D0D5DD"/>
+                      </a:solidFill>
+                      <a:prstDash val="solid"/>
+                      <a:round/>
+                      <a:headEnd type="none" w="med" len="med"/>
+                      <a:tailEnd type="none" w="med" len="med"/>
+                    </a:lnB>
+                    <a:solidFill>
+                      <a:schemeClr val="accent5"/>
+                    </a:solidFill>
+                  </a:tcPr>
+                </a:tc>
+                <a:tc>
+                  <a:txBody>
+                    <a:bodyPr/>
+                    <a:lstStyle/>
+                    <a:p>
+                      <a:pPr indent="0" marL="0">
+                        <a:buNone/>
+                      </a:pPr>
+                      <a:r>
+                        <a:rPr lang="en-US" sz="1200" b="1" dirty="0">
+                          <a:solidFill>
+                            <a:schemeClr val="accent1"/>
+                          </a:solidFill>
+                        </a:rPr>
+                        <a:t>138</a:t>
+                      </a:r>
+                      <a:endParaRPr lang="en-US" sz="1200" dirty="0"/>
+                    </a:p>
+                  </a:txBody>
+                  <a:tcPr marL="91440" marR="91440" marT="45720" marB="45720">
+                    <a:lnL w="6350" cap="flat" cmpd="sng" algn="ctr">
+                      <a:solidFill>
+                        <a:srgbClr val="D0D5DD"/>
+                      </a:solidFill>
+                      <a:prstDash val="solid"/>
+                      <a:round/>
+                      <a:headEnd type="none" w="med" len="med"/>
+                      <a:tailEnd type="none" w="med" len="med"/>
+                    </a:lnL>
+                    <a:lnR w="6350" cap="flat" cmpd="sng" algn="ctr">
+                      <a:solidFill>
+                        <a:srgbClr val="D0D5DD"/>
+                      </a:solidFill>
+                      <a:prstDash val="solid"/>
+                      <a:round/>
+                      <a:headEnd type="none" w="med" len="med"/>
+                      <a:tailEnd type="none" w="med" len="med"/>
+                    </a:lnR>
+                    <a:lnT w="6350" cap="flat" cmpd="sng" algn="ctr">
+                      <a:solidFill>
+                        <a:srgbClr val="D0D5DD"/>
+                      </a:solidFill>
+                      <a:prstDash val="solid"/>
+                      <a:round/>
+                      <a:headEnd type="none" w="med" len="med"/>
+                      <a:tailEnd type="none" w="med" len="med"/>
+                    </a:lnT>
+                    <a:lnB w="6350" cap="flat" cmpd="sng" algn="ctr">
+                      <a:solidFill>
+                        <a:srgbClr val="D0D5DD"/>
+                      </a:solidFill>
+                      <a:prstDash val="solid"/>
+                      <a:round/>
+                      <a:headEnd type="none" w="med" len="med"/>
+                      <a:tailEnd type="none" w="med" len="med"/>
+                    </a:lnB>
+                    <a:solidFill>
+                      <a:schemeClr val="accent5"/>
+                    </a:solidFill>
+                  </a:tcPr>
+                </a:tc>
+                <a:tc>
+                  <a:txBody>
+                    <a:bodyPr/>
+                    <a:lstStyle/>
+                    <a:p>
+                      <a:pPr indent="0" marL="0">
+                        <a:buNone/>
+                      </a:pPr>
+                      <a:r>
+                        <a:rPr lang="en-US" sz="1200" b="1" dirty="0">
+                          <a:solidFill>
+                            <a:schemeClr val="accent1"/>
+                          </a:solidFill>
+                        </a:rPr>
+                        <a:t>57.26</a:t>
+                      </a:r>
+                      <a:endParaRPr lang="en-US" sz="1200" dirty="0"/>
+                    </a:p>
+                  </a:txBody>
+                  <a:tcPr marL="91440" marR="91440" marT="45720" marB="45720">
+                    <a:lnL w="6350" cap="flat" cmpd="sng" algn="ctr">
+                      <a:solidFill>
+                        <a:srgbClr val="D0D5DD"/>
+                      </a:solidFill>
+                      <a:prstDash val="solid"/>
+                      <a:round/>
+                      <a:headEnd type="none" w="med" len="med"/>
+                      <a:tailEnd type="none" w="med" len="med"/>
+                    </a:lnL>
+                    <a:lnR w="6350" cap="flat" cmpd="sng" algn="ctr">
+                      <a:solidFill>
+                        <a:srgbClr val="D0D5DD"/>
+                      </a:solidFill>
+                      <a:prstDash val="solid"/>
+                      <a:round/>
+                      <a:headEnd type="none" w="med" len="med"/>
+                      <a:tailEnd type="none" w="med" len="med"/>
+                    </a:lnR>
+                    <a:lnT w="6350" cap="flat" cmpd="sng" algn="ctr">
+                      <a:solidFill>
+                        <a:srgbClr val="D0D5DD"/>
+                      </a:solidFill>
+                      <a:prstDash val="solid"/>
+                      <a:round/>
+                      <a:headEnd type="none" w="med" len="med"/>
+                      <a:tailEnd type="none" w="med" len="med"/>
+                    </a:lnT>
+                    <a:lnB w="6350" cap="flat" cmpd="sng" algn="ctr">
+                      <a:solidFill>
+                        <a:srgbClr val="D0D5DD"/>
+                      </a:solidFill>
+                      <a:prstDash val="solid"/>
+                      <a:round/>
+                      <a:headEnd type="none" w="med" len="med"/>
+                      <a:tailEnd type="none" w="med" len="med"/>
+                    </a:lnB>
+                    <a:solidFill>
+                      <a:schemeClr val="accent5"/>
+                    </a:solidFill>
+                  </a:tcPr>
+                </a:tc>
+              </a:tr>
+              <a:tr h="329184">
+                <a:tc>
+                  <a:txBody>
+                    <a:bodyPr/>
+                    <a:lstStyle/>
+                    <a:p>
+                      <a:pPr indent="0" marL="0">
+                        <a:buNone/>
+                      </a:pPr>
+                      <a:r>
+                        <a:rPr lang="en-US" sz="1200" dirty="0">
+                          <a:solidFill>
+                            <a:schemeClr val="tx1"/>
+                          </a:solidFill>
+                        </a:rPr>
+                        <a:t>Logistic Regression</a:t>
+                      </a:r>
+                      <a:endParaRPr lang="en-US" sz="1200" dirty="0"/>
+                    </a:p>
+                  </a:txBody>
+                  <a:tcPr marL="91440" marR="91440" marT="45720" marB="45720">
+                    <a:lnL w="6350" cap="flat" cmpd="sng" algn="ctr">
+                      <a:solidFill>
+                        <a:srgbClr val="D0D5DD"/>
+                      </a:solidFill>
+                      <a:prstDash val="solid"/>
+                      <a:round/>
+                      <a:headEnd type="none" w="med" len="med"/>
+                      <a:tailEnd type="none" w="med" len="med"/>
+                    </a:lnL>
+                    <a:lnR w="6350" cap="flat" cmpd="sng" algn="ctr">
+                      <a:solidFill>
+                        <a:srgbClr val="D0D5DD"/>
+                      </a:solidFill>
+                      <a:prstDash val="solid"/>
+                      <a:round/>
+                      <a:headEnd type="none" w="med" len="med"/>
+                      <a:tailEnd type="none" w="med" len="med"/>
+                    </a:lnR>
+                    <a:lnT w="6350" cap="flat" cmpd="sng" algn="ctr">
+                      <a:solidFill>
+                        <a:srgbClr val="D0D5DD"/>
+                      </a:solidFill>
+                      <a:prstDash val="solid"/>
+                      <a:round/>
+                      <a:headEnd type="none" w="med" len="med"/>
+                      <a:tailEnd type="none" w="med" len="med"/>
+                    </a:lnT>
+                    <a:lnB w="6350" cap="flat" cmpd="sng" algn="ctr">
+                      <a:solidFill>
+                        <a:srgbClr val="D0D5DD"/>
+                      </a:solidFill>
+                      <a:prstDash val="solid"/>
+                      <a:round/>
+                      <a:headEnd type="none" w="med" len="med"/>
+                      <a:tailEnd type="none" w="med" len="med"/>
+                    </a:lnB>
+                  </a:tcPr>
+                </a:tc>
+                <a:tc>
+                  <a:txBody>
+                    <a:bodyPr/>
+                    <a:lstStyle/>
+                    <a:p>
+                      <a:pPr indent="0" marL="0">
+                        <a:buNone/>
+                      </a:pPr>
+                      <a:r>
+                        <a:rPr lang="en-US" sz="1200" dirty="0">
+                          <a:solidFill>
+                            <a:schemeClr val="tx1"/>
+                          </a:solidFill>
+                        </a:rPr>
+                        <a:t>139</a:t>
+                      </a:r>
+                      <a:endParaRPr lang="en-US" sz="1200" dirty="0"/>
+                    </a:p>
+                  </a:txBody>
+                  <a:tcPr marL="91440" marR="91440" marT="45720" marB="45720">
+                    <a:lnL w="6350" cap="flat" cmpd="sng" algn="ctr">
+                      <a:solidFill>
+                        <a:srgbClr val="D0D5DD"/>
+                      </a:solidFill>
+                      <a:prstDash val="solid"/>
+                      <a:round/>
+                      <a:headEnd type="none" w="med" len="med"/>
+                      <a:tailEnd type="none" w="med" len="med"/>
+                    </a:lnL>
+                    <a:lnR w="6350" cap="flat" cmpd="sng" algn="ctr">
+                      <a:solidFill>
+                        <a:srgbClr val="D0D5DD"/>
+                      </a:solidFill>
+                      <a:prstDash val="solid"/>
+                      <a:round/>
+                      <a:headEnd type="none" w="med" len="med"/>
+                      <a:tailEnd type="none" w="med" len="med"/>
+                    </a:lnR>
+                    <a:lnT w="6350" cap="flat" cmpd="sng" algn="ctr">
+                      <a:solidFill>
+                        <a:srgbClr val="D0D5DD"/>
+                      </a:solidFill>
+                      <a:prstDash val="solid"/>
+                      <a:round/>
+                      <a:headEnd type="none" w="med" len="med"/>
+                      <a:tailEnd type="none" w="med" len="med"/>
+                    </a:lnT>
+                    <a:lnB w="6350" cap="flat" cmpd="sng" algn="ctr">
+                      <a:solidFill>
+                        <a:srgbClr val="D0D5DD"/>
+                      </a:solidFill>
+                      <a:prstDash val="solid"/>
+                      <a:round/>
+                      <a:headEnd type="none" w="med" len="med"/>
+                      <a:tailEnd type="none" w="med" len="med"/>
+                    </a:lnB>
+                  </a:tcPr>
+                </a:tc>
+                <a:tc>
+                  <a:txBody>
+                    <a:bodyPr/>
+                    <a:lstStyle/>
+                    <a:p>
+                      <a:pPr indent="0" marL="0">
+                        <a:buNone/>
+                      </a:pPr>
+                      <a:r>
+                        <a:rPr lang="en-US" sz="1200" dirty="0">
+                          <a:solidFill>
+                            <a:schemeClr val="tx1"/>
+                          </a:solidFill>
+                        </a:rPr>
+                        <a:t>57.68</a:t>
+                      </a:r>
+                      <a:endParaRPr lang="en-US" sz="1200" dirty="0"/>
+                    </a:p>
+                  </a:txBody>
+                  <a:tcPr marL="91440" marR="91440" marT="45720" marB="45720">
+                    <a:lnL w="6350" cap="flat" cmpd="sng" algn="ctr">
+                      <a:solidFill>
+                        <a:srgbClr val="D0D5DD"/>
+                      </a:solidFill>
+                      <a:prstDash val="solid"/>
+                      <a:round/>
+                      <a:headEnd type="none" w="med" len="med"/>
+                      <a:tailEnd type="none" w="med" len="med"/>
+                    </a:lnL>
+                    <a:lnR w="6350" cap="flat" cmpd="sng" algn="ctr">
+                      <a:solidFill>
+                        <a:srgbClr val="D0D5DD"/>
+                      </a:solidFill>
+                      <a:prstDash val="solid"/>
+                      <a:round/>
+                      <a:headEnd type="none" w="med" len="med"/>
+                      <a:tailEnd type="none" w="med" len="med"/>
+                    </a:lnR>
+                    <a:lnT w="6350" cap="flat" cmpd="sng" algn="ctr">
+                      <a:solidFill>
+                        <a:srgbClr val="D0D5DD"/>
+                      </a:solidFill>
+                      <a:prstDash val="solid"/>
+                      <a:round/>
+                      <a:headEnd type="none" w="med" len="med"/>
+                      <a:tailEnd type="none" w="med" len="med"/>
+                    </a:lnT>
+                    <a:lnB w="6350" cap="flat" cmpd="sng" algn="ctr">
+                      <a:solidFill>
+                        <a:srgbClr val="D0D5DD"/>
+                      </a:solidFill>
+                      <a:prstDash val="solid"/>
+                      <a:round/>
+                      <a:headEnd type="none" w="med" len="med"/>
+                      <a:tailEnd type="none" w="med" len="med"/>
+                    </a:lnB>
+                  </a:tcPr>
+                </a:tc>
+                <a:tc>
+                  <a:txBody>
+                    <a:bodyPr/>
+                    <a:lstStyle/>
+                    <a:p>
+                      <a:pPr indent="0" marL="0">
+                        <a:buNone/>
+                      </a:pPr>
+                      <a:r>
+                        <a:rPr lang="en-US" sz="1200" dirty="0">
+                          <a:solidFill>
+                            <a:schemeClr val="tx1"/>
+                          </a:solidFill>
+                        </a:rPr>
+                        <a:t>143</a:t>
+                      </a:r>
+                      <a:endParaRPr lang="en-US" sz="1200" dirty="0"/>
+                    </a:p>
+                  </a:txBody>
+                  <a:tcPr marL="91440" marR="91440" marT="45720" marB="45720">
+                    <a:lnL w="6350" cap="flat" cmpd="sng" algn="ctr">
+                      <a:solidFill>
+                        <a:srgbClr val="D0D5DD"/>
+                      </a:solidFill>
+                      <a:prstDash val="solid"/>
+                      <a:round/>
+                      <a:headEnd type="none" w="med" len="med"/>
+                      <a:tailEnd type="none" w="med" len="med"/>
+                    </a:lnL>
+                    <a:lnR w="6350" cap="flat" cmpd="sng" algn="ctr">
+                      <a:solidFill>
+                        <a:srgbClr val="D0D5DD"/>
+                      </a:solidFill>
+                      <a:prstDash val="solid"/>
+                      <a:round/>
+                      <a:headEnd type="none" w="med" len="med"/>
+                      <a:tailEnd type="none" w="med" len="med"/>
+                    </a:lnR>
+                    <a:lnT w="6350" cap="flat" cmpd="sng" algn="ctr">
+                      <a:solidFill>
+                        <a:srgbClr val="D0D5DD"/>
+                      </a:solidFill>
+                      <a:prstDash val="solid"/>
+                      <a:round/>
+                      <a:headEnd type="none" w="med" len="med"/>
+                      <a:tailEnd type="none" w="med" len="med"/>
+                    </a:lnT>
+                    <a:lnB w="6350" cap="flat" cmpd="sng" algn="ctr">
+                      <a:solidFill>
+                        <a:srgbClr val="D0D5DD"/>
+                      </a:solidFill>
+                      <a:prstDash val="solid"/>
+                      <a:round/>
+                      <a:headEnd type="none" w="med" len="med"/>
+                      <a:tailEnd type="none" w="med" len="med"/>
+                    </a:lnB>
+                  </a:tcPr>
+                </a:tc>
+                <a:tc>
+                  <a:txBody>
+                    <a:bodyPr/>
+                    <a:lstStyle/>
+                    <a:p>
+                      <a:pPr indent="0" marL="0">
+                        <a:buNone/>
+                      </a:pPr>
+                      <a:r>
+                        <a:rPr lang="en-US" sz="1200" b="1" dirty="0">
+                          <a:solidFill>
+                            <a:schemeClr val="accent3"/>
+                          </a:solidFill>
+                        </a:rPr>
+                        <a:t>59.34</a:t>
+                      </a:r>
+                      <a:endParaRPr lang="en-US" sz="1200" dirty="0"/>
+                    </a:p>
+                  </a:txBody>
+                  <a:tcPr marL="91440" marR="91440" marT="45720" marB="45720">
+                    <a:lnL w="6350" cap="flat" cmpd="sng" algn="ctr">
+                      <a:solidFill>
+                        <a:srgbClr val="D0D5DD"/>
+                      </a:solidFill>
+                      <a:prstDash val="solid"/>
+                      <a:round/>
+                      <a:headEnd type="none" w="med" len="med"/>
+                      <a:tailEnd type="none" w="med" len="med"/>
+                    </a:lnL>
+                    <a:lnR w="6350" cap="flat" cmpd="sng" algn="ctr">
+                      <a:solidFill>
+                        <a:srgbClr val="D0D5DD"/>
+                      </a:solidFill>
+                      <a:prstDash val="solid"/>
+                      <a:round/>
+                      <a:headEnd type="none" w="med" len="med"/>
+                      <a:tailEnd type="none" w="med" len="med"/>
+                    </a:lnR>
+                    <a:lnT w="6350" cap="flat" cmpd="sng" algn="ctr">
+                      <a:solidFill>
+                        <a:srgbClr val="D0D5DD"/>
+                      </a:solidFill>
+                      <a:prstDash val="solid"/>
+                      <a:round/>
+                      <a:headEnd type="none" w="med" len="med"/>
+                      <a:tailEnd type="none" w="med" len="med"/>
+                    </a:lnT>
+                    <a:lnB w="6350" cap="flat" cmpd="sng" algn="ctr">
+                      <a:solidFill>
+                        <a:srgbClr val="D0D5DD"/>
+                      </a:solidFill>
+                      <a:prstDash val="solid"/>
+                      <a:round/>
+                      <a:headEnd type="none" w="med" len="med"/>
+                      <a:tailEnd type="none" w="med" len="med"/>
+                    </a:lnB>
+                  </a:tcPr>
+                </a:tc>
+              </a:tr>
+              <a:tr h="329184">
+                <a:tc>
+                  <a:txBody>
+                    <a:bodyPr/>
+                    <a:lstStyle/>
+                    <a:p>
+                      <a:pPr indent="0" marL="0">
+                        <a:buNone/>
+                      </a:pPr>
+                      <a:r>
+                        <a:rPr lang="en-US" sz="1200" dirty="0">
+                          <a:solidFill>
+                            <a:schemeClr val="tx1"/>
+                          </a:solidFill>
+                        </a:rPr>
+                        <a:t>LDA</a:t>
+                      </a:r>
+                      <a:endParaRPr lang="en-US" sz="1200" dirty="0"/>
+                    </a:p>
+                  </a:txBody>
+                  <a:tcPr marL="91440" marR="91440" marT="45720" marB="45720">
+                    <a:lnL w="6350" cap="flat" cmpd="sng" algn="ctr">
+                      <a:solidFill>
+                        <a:srgbClr val="D0D5DD"/>
+                      </a:solidFill>
+                      <a:prstDash val="solid"/>
+                      <a:round/>
+                      <a:headEnd type="none" w="med" len="med"/>
+                      <a:tailEnd type="none" w="med" len="med"/>
+                    </a:lnL>
+                    <a:lnR w="6350" cap="flat" cmpd="sng" algn="ctr">
+                      <a:solidFill>
+                        <a:srgbClr val="D0D5DD"/>
+                      </a:solidFill>
+                      <a:prstDash val="solid"/>
+                      <a:round/>
+                      <a:headEnd type="none" w="med" len="med"/>
+                      <a:tailEnd type="none" w="med" len="med"/>
+                    </a:lnR>
+                    <a:lnT w="6350" cap="flat" cmpd="sng" algn="ctr">
+                      <a:solidFill>
+                        <a:srgbClr val="D0D5DD"/>
+                      </a:solidFill>
+                      <a:prstDash val="solid"/>
+                      <a:round/>
+                      <a:headEnd type="none" w="med" len="med"/>
+                      <a:tailEnd type="none" w="med" len="med"/>
+                    </a:lnT>
+                    <a:lnB w="6350" cap="flat" cmpd="sng" algn="ctr">
+                      <a:solidFill>
+                        <a:srgbClr val="D0D5DD"/>
+                      </a:solidFill>
+                      <a:prstDash val="solid"/>
+                      <a:round/>
+                      <a:headEnd type="none" w="med" len="med"/>
+                      <a:tailEnd type="none" w="med" len="med"/>
+                    </a:lnB>
+                  </a:tcPr>
+                </a:tc>
+                <a:tc>
+                  <a:txBody>
+                    <a:bodyPr/>
+                    <a:lstStyle/>
+                    <a:p>
+                      <a:pPr indent="0" marL="0">
+                        <a:buNone/>
+                      </a:pPr>
+                      <a:r>
+                        <a:rPr lang="en-US" sz="1200" dirty="0">
+                          <a:solidFill>
+                            <a:schemeClr val="tx1"/>
+                          </a:solidFill>
+                        </a:rPr>
+                        <a:t>137</a:t>
+                      </a:r>
+                      <a:endParaRPr lang="en-US" sz="1200" dirty="0"/>
+                    </a:p>
+                  </a:txBody>
+                  <a:tcPr marL="91440" marR="91440" marT="45720" marB="45720">
+                    <a:lnL w="6350" cap="flat" cmpd="sng" algn="ctr">
+                      <a:solidFill>
+                        <a:srgbClr val="D0D5DD"/>
+                      </a:solidFill>
+                      <a:prstDash val="solid"/>
+                      <a:round/>
+                      <a:headEnd type="none" w="med" len="med"/>
+                      <a:tailEnd type="none" w="med" len="med"/>
+                    </a:lnL>
+                    <a:lnR w="6350" cap="flat" cmpd="sng" algn="ctr">
+                      <a:solidFill>
+                        <a:srgbClr val="D0D5DD"/>
+                      </a:solidFill>
+                      <a:prstDash val="solid"/>
+                      <a:round/>
+                      <a:headEnd type="none" w="med" len="med"/>
+                      <a:tailEnd type="none" w="med" len="med"/>
+                    </a:lnR>
+                    <a:lnT w="6350" cap="flat" cmpd="sng" algn="ctr">
+                      <a:solidFill>
+                        <a:srgbClr val="D0D5DD"/>
+                      </a:solidFill>
+                      <a:prstDash val="solid"/>
+                      <a:round/>
+                      <a:headEnd type="none" w="med" len="med"/>
+                      <a:tailEnd type="none" w="med" len="med"/>
+                    </a:lnT>
+                    <a:lnB w="6350" cap="flat" cmpd="sng" algn="ctr">
+                      <a:solidFill>
+                        <a:srgbClr val="D0D5DD"/>
+                      </a:solidFill>
+                      <a:prstDash val="solid"/>
+                      <a:round/>
+                      <a:headEnd type="none" w="med" len="med"/>
+                      <a:tailEnd type="none" w="med" len="med"/>
+                    </a:lnB>
+                  </a:tcPr>
+                </a:tc>
+                <a:tc>
+                  <a:txBody>
+                    <a:bodyPr/>
+                    <a:lstStyle/>
+                    <a:p>
+                      <a:pPr indent="0" marL="0">
+                        <a:buNone/>
+                      </a:pPr>
+                      <a:r>
+                        <a:rPr lang="en-US" sz="1200" dirty="0">
+                          <a:solidFill>
+                            <a:schemeClr val="tx1"/>
+                          </a:solidFill>
+                        </a:rPr>
+                        <a:t>56.85</a:t>
+                      </a:r>
+                      <a:endParaRPr lang="en-US" sz="1200" dirty="0"/>
+                    </a:p>
+                  </a:txBody>
+                  <a:tcPr marL="91440" marR="91440" marT="45720" marB="45720">
+                    <a:lnL w="6350" cap="flat" cmpd="sng" algn="ctr">
+                      <a:solidFill>
+                        <a:srgbClr val="D0D5DD"/>
+                      </a:solidFill>
+                      <a:prstDash val="solid"/>
+                      <a:round/>
+                      <a:headEnd type="none" w="med" len="med"/>
+                      <a:tailEnd type="none" w="med" len="med"/>
+                    </a:lnL>
+                    <a:lnR w="6350" cap="flat" cmpd="sng" algn="ctr">
+                      <a:solidFill>
+                        <a:srgbClr val="D0D5DD"/>
+                      </a:solidFill>
+                      <a:prstDash val="solid"/>
+                      <a:round/>
+                      <a:headEnd type="none" w="med" len="med"/>
+                      <a:tailEnd type="none" w="med" len="med"/>
+                    </a:lnR>
+                    <a:lnT w="6350" cap="flat" cmpd="sng" algn="ctr">
+                      <a:solidFill>
+                        <a:srgbClr val="D0D5DD"/>
+                      </a:solidFill>
+                      <a:prstDash val="solid"/>
+                      <a:round/>
+                      <a:headEnd type="none" w="med" len="med"/>
+                      <a:tailEnd type="none" w="med" len="med"/>
+                    </a:lnT>
+                    <a:lnB w="6350" cap="flat" cmpd="sng" algn="ctr">
+                      <a:solidFill>
+                        <a:srgbClr val="D0D5DD"/>
+                      </a:solidFill>
+                      <a:prstDash val="solid"/>
+                      <a:round/>
+                      <a:headEnd type="none" w="med" len="med"/>
+                      <a:tailEnd type="none" w="med" len="med"/>
+                    </a:lnB>
+                  </a:tcPr>
+                </a:tc>
+                <a:tc>
+                  <a:txBody>
+                    <a:bodyPr/>
+                    <a:lstStyle/>
+                    <a:p>
+                      <a:pPr indent="0" marL="0">
+                        <a:buNone/>
+                      </a:pPr>
+                      <a:r>
+                        <a:rPr lang="en-US" sz="1200" dirty="0">
+                          <a:solidFill>
+                            <a:schemeClr val="tx1"/>
+                          </a:solidFill>
+                        </a:rPr>
+                        <a:t>143</a:t>
+                      </a:r>
+                      <a:endParaRPr lang="en-US" sz="1200" dirty="0"/>
+                    </a:p>
+                  </a:txBody>
+                  <a:tcPr marL="91440" marR="91440" marT="45720" marB="45720">
+                    <a:lnL w="6350" cap="flat" cmpd="sng" algn="ctr">
+                      <a:solidFill>
+                        <a:srgbClr val="D0D5DD"/>
+                      </a:solidFill>
+                      <a:prstDash val="solid"/>
+                      <a:round/>
+                      <a:headEnd type="none" w="med" len="med"/>
+                      <a:tailEnd type="none" w="med" len="med"/>
+                    </a:lnL>
+                    <a:lnR w="6350" cap="flat" cmpd="sng" algn="ctr">
+                      <a:solidFill>
+                        <a:srgbClr val="D0D5DD"/>
+                      </a:solidFill>
+                      <a:prstDash val="solid"/>
+                      <a:round/>
+                      <a:headEnd type="none" w="med" len="med"/>
+                      <a:tailEnd type="none" w="med" len="med"/>
+                    </a:lnR>
+                    <a:lnT w="6350" cap="flat" cmpd="sng" algn="ctr">
+                      <a:solidFill>
+                        <a:srgbClr val="D0D5DD"/>
+                      </a:solidFill>
+                      <a:prstDash val="solid"/>
+                      <a:round/>
+                      <a:headEnd type="none" w="med" len="med"/>
+                      <a:tailEnd type="none" w="med" len="med"/>
+                    </a:lnT>
+                    <a:lnB w="6350" cap="flat" cmpd="sng" algn="ctr">
+                      <a:solidFill>
+                        <a:srgbClr val="D0D5DD"/>
+                      </a:solidFill>
+                      <a:prstDash val="solid"/>
+                      <a:round/>
+                      <a:headEnd type="none" w="med" len="med"/>
+                      <a:tailEnd type="none" w="med" len="med"/>
+                    </a:lnB>
+                  </a:tcPr>
+                </a:tc>
+                <a:tc>
+                  <a:txBody>
+                    <a:bodyPr/>
+                    <a:lstStyle/>
+                    <a:p>
+                      <a:pPr indent="0" marL="0">
+                        <a:buNone/>
+                      </a:pPr>
+                      <a:r>
+                        <a:rPr lang="en-US" sz="1200" b="1" dirty="0">
+                          <a:solidFill>
+                            <a:schemeClr val="accent3"/>
+                          </a:solidFill>
+                        </a:rPr>
+                        <a:t>59.34</a:t>
+                      </a:r>
+                      <a:endParaRPr lang="en-US" sz="1200" dirty="0"/>
+                    </a:p>
+                  </a:txBody>
+                  <a:tcPr marL="91440" marR="91440" marT="45720" marB="45720">
+                    <a:lnL w="6350" cap="flat" cmpd="sng" algn="ctr">
+                      <a:solidFill>
+                        <a:srgbClr val="D0D5DD"/>
+                      </a:solidFill>
+                      <a:prstDash val="solid"/>
+                      <a:round/>
+                      <a:headEnd type="none" w="med" len="med"/>
+                      <a:tailEnd type="none" w="med" len="med"/>
+                    </a:lnL>
+                    <a:lnR w="6350" cap="flat" cmpd="sng" algn="ctr">
+                      <a:solidFill>
+                        <a:srgbClr val="D0D5DD"/>
+                      </a:solidFill>
+                      <a:prstDash val="solid"/>
+                      <a:round/>
+                      <a:headEnd type="none" w="med" len="med"/>
+                      <a:tailEnd type="none" w="med" len="med"/>
+                    </a:lnR>
+                    <a:lnT w="6350" cap="flat" cmpd="sng" algn="ctr">
+                      <a:solidFill>
+                        <a:srgbClr val="D0D5DD"/>
+                      </a:solidFill>
+                      <a:prstDash val="solid"/>
+                      <a:round/>
+                      <a:headEnd type="none" w="med" len="med"/>
+                      <a:tailEnd type="none" w="med" len="med"/>
+                    </a:lnT>
+                    <a:lnB w="6350" cap="flat" cmpd="sng" algn="ctr">
+                      <a:solidFill>
+                        <a:srgbClr val="D0D5DD"/>
+                      </a:solidFill>
+                      <a:prstDash val="solid"/>
+                      <a:round/>
+                      <a:headEnd type="none" w="med" len="med"/>
+                      <a:tailEnd type="none" w="med" len="med"/>
+                    </a:lnB>
+                  </a:tcPr>
+                </a:tc>
+              </a:tr>
+              <a:tr h="329184">
+                <a:tc>
+                  <a:txBody>
+                    <a:bodyPr/>
+                    <a:lstStyle/>
+                    <a:p>
+                      <a:pPr indent="0" marL="0">
+                        <a:buNone/>
+                      </a:pPr>
+                      <a:r>
+                        <a:rPr lang="en-US" sz="1200" dirty="0">
+                          <a:solidFill>
+                            <a:schemeClr val="tx1"/>
+                          </a:solidFill>
+                        </a:rPr>
+                        <a:t>SVM (RBF)</a:t>
+                      </a:r>
+                      <a:endParaRPr lang="en-US" sz="1200" dirty="0"/>
+                    </a:p>
+                  </a:txBody>
+                  <a:tcPr marL="91440" marR="91440" marT="45720" marB="45720">
+                    <a:lnL w="6350" cap="flat" cmpd="sng" algn="ctr">
+                      <a:solidFill>
+                        <a:srgbClr val="D0D5DD"/>
+                      </a:solidFill>
+                      <a:prstDash val="solid"/>
+                      <a:round/>
+                      <a:headEnd type="none" w="med" len="med"/>
+                      <a:tailEnd type="none" w="med" len="med"/>
+                    </a:lnL>
+                    <a:lnR w="6350" cap="flat" cmpd="sng" algn="ctr">
+                      <a:solidFill>
+                        <a:srgbClr val="D0D5DD"/>
+                      </a:solidFill>
+                      <a:prstDash val="solid"/>
+                      <a:round/>
+                      <a:headEnd type="none" w="med" len="med"/>
+                      <a:tailEnd type="none" w="med" len="med"/>
+                    </a:lnR>
+                    <a:lnT w="6350" cap="flat" cmpd="sng" algn="ctr">
+                      <a:solidFill>
+                        <a:srgbClr val="D0D5DD"/>
+                      </a:solidFill>
+                      <a:prstDash val="solid"/>
+                      <a:round/>
+                      <a:headEnd type="none" w="med" len="med"/>
+                      <a:tailEnd type="none" w="med" len="med"/>
+                    </a:lnT>
+                    <a:lnB w="6350" cap="flat" cmpd="sng" algn="ctr">
+                      <a:solidFill>
+                        <a:srgbClr val="D0D5DD"/>
+                      </a:solidFill>
+                      <a:prstDash val="solid"/>
+                      <a:round/>
+                      <a:headEnd type="none" w="med" len="med"/>
+                      <a:tailEnd type="none" w="med" len="med"/>
+                    </a:lnB>
+                  </a:tcPr>
+                </a:tc>
+                <a:tc>
+                  <a:txBody>
+                    <a:bodyPr/>
+                    <a:lstStyle/>
+                    <a:p>
+                      <a:pPr indent="0" marL="0">
+                        <a:buNone/>
+                      </a:pPr>
+                      <a:r>
+                        <a:rPr lang="en-US" sz="1200" dirty="0">
+                          <a:solidFill>
+                            <a:schemeClr val="tx1"/>
+                          </a:solidFill>
+                        </a:rPr>
+                        <a:t>131</a:t>
+                      </a:r>
+                      <a:endParaRPr lang="en-US" sz="1200" dirty="0"/>
+                    </a:p>
+                  </a:txBody>
+                  <a:tcPr marL="91440" marR="91440" marT="45720" marB="45720">
+                    <a:lnL w="6350" cap="flat" cmpd="sng" algn="ctr">
+                      <a:solidFill>
+                        <a:srgbClr val="D0D5DD"/>
+                      </a:solidFill>
+                      <a:prstDash val="solid"/>
+                      <a:round/>
+                      <a:headEnd type="none" w="med" len="med"/>
+                      <a:tailEnd type="none" w="med" len="med"/>
+                    </a:lnL>
+                    <a:lnR w="6350" cap="flat" cmpd="sng" algn="ctr">
+                      <a:solidFill>
+                        <a:srgbClr val="D0D5DD"/>
+                      </a:solidFill>
+                      <a:prstDash val="solid"/>
+                      <a:round/>
+                      <a:headEnd type="none" w="med" len="med"/>
+                      <a:tailEnd type="none" w="med" len="med"/>
+                    </a:lnR>
+                    <a:lnT w="6350" cap="flat" cmpd="sng" algn="ctr">
+                      <a:solidFill>
+                        <a:srgbClr val="D0D5DD"/>
+                      </a:solidFill>
+                      <a:prstDash val="solid"/>
+                      <a:round/>
+                      <a:headEnd type="none" w="med" len="med"/>
+                      <a:tailEnd type="none" w="med" len="med"/>
+                    </a:lnT>
+                    <a:lnB w="6350" cap="flat" cmpd="sng" algn="ctr">
+                      <a:solidFill>
+                        <a:srgbClr val="D0D5DD"/>
+                      </a:solidFill>
+                      <a:prstDash val="solid"/>
+                      <a:round/>
+                      <a:headEnd type="none" w="med" len="med"/>
+                      <a:tailEnd type="none" w="med" len="med"/>
+                    </a:lnB>
+                  </a:tcPr>
+                </a:tc>
+                <a:tc>
+                  <a:txBody>
+                    <a:bodyPr/>
+                    <a:lstStyle/>
+                    <a:p>
+                      <a:pPr indent="0" marL="0">
+                        <a:buNone/>
+                      </a:pPr>
+                      <a:r>
+                        <a:rPr lang="en-US" sz="1200" dirty="0">
+                          <a:solidFill>
+                            <a:schemeClr val="tx1"/>
+                          </a:solidFill>
+                        </a:rPr>
+                        <a:t>54.36</a:t>
+                      </a:r>
+                      <a:endParaRPr lang="en-US" sz="1200" dirty="0"/>
+                    </a:p>
+                  </a:txBody>
+                  <a:tcPr marL="91440" marR="91440" marT="45720" marB="45720">
+                    <a:lnL w="6350" cap="flat" cmpd="sng" algn="ctr">
+                      <a:solidFill>
+                        <a:srgbClr val="D0D5DD"/>
+                      </a:solidFill>
+                      <a:prstDash val="solid"/>
+                      <a:round/>
+                      <a:headEnd type="none" w="med" len="med"/>
+                      <a:tailEnd type="none" w="med" len="med"/>
+                    </a:lnL>
+                    <a:lnR w="6350" cap="flat" cmpd="sng" algn="ctr">
+                      <a:solidFill>
+                        <a:srgbClr val="D0D5DD"/>
+                      </a:solidFill>
+                      <a:prstDash val="solid"/>
+                      <a:round/>
+                      <a:headEnd type="none" w="med" len="med"/>
+                      <a:tailEnd type="none" w="med" len="med"/>
+                    </a:lnR>
+                    <a:lnT w="6350" cap="flat" cmpd="sng" algn="ctr">
+                      <a:solidFill>
+                        <a:srgbClr val="D0D5DD"/>
+                      </a:solidFill>
+                      <a:prstDash val="solid"/>
+                      <a:round/>
+                      <a:headEnd type="none" w="med" len="med"/>
+                      <a:tailEnd type="none" w="med" len="med"/>
+                    </a:lnT>
+                    <a:lnB w="6350" cap="flat" cmpd="sng" algn="ctr">
+                      <a:solidFill>
+                        <a:srgbClr val="D0D5DD"/>
+                      </a:solidFill>
+                      <a:prstDash val="solid"/>
+                      <a:round/>
+                      <a:headEnd type="none" w="med" len="med"/>
+                      <a:tailEnd type="none" w="med" len="med"/>
+                    </a:lnB>
+                  </a:tcPr>
+                </a:tc>
+                <a:tc>
+                  <a:txBody>
+                    <a:bodyPr/>
+                    <a:lstStyle/>
+                    <a:p>
+                      <a:pPr indent="0" marL="0">
+                        <a:buNone/>
+                      </a:pPr>
+                      <a:r>
+                        <a:rPr lang="en-US" sz="1200" dirty="0">
+                          <a:solidFill>
+                            <a:schemeClr val="tx1"/>
+                          </a:solidFill>
+                        </a:rPr>
+                        <a:t>132</a:t>
+                      </a:r>
+                      <a:endParaRPr lang="en-US" sz="1200" dirty="0"/>
+                    </a:p>
+                  </a:txBody>
+                  <a:tcPr marL="91440" marR="91440" marT="45720" marB="45720">
+                    <a:lnL w="6350" cap="flat" cmpd="sng" algn="ctr">
+                      <a:solidFill>
+                        <a:srgbClr val="D0D5DD"/>
+                      </a:solidFill>
+                      <a:prstDash val="solid"/>
+                      <a:round/>
+                      <a:headEnd type="none" w="med" len="med"/>
+                      <a:tailEnd type="none" w="med" len="med"/>
+                    </a:lnL>
+                    <a:lnR w="6350" cap="flat" cmpd="sng" algn="ctr">
+                      <a:solidFill>
+                        <a:srgbClr val="D0D5DD"/>
+                      </a:solidFill>
+                      <a:prstDash val="solid"/>
+                      <a:round/>
+                      <a:headEnd type="none" w="med" len="med"/>
+                      <a:tailEnd type="none" w="med" len="med"/>
+                    </a:lnR>
+                    <a:lnT w="6350" cap="flat" cmpd="sng" algn="ctr">
+                      <a:solidFill>
+                        <a:srgbClr val="D0D5DD"/>
+                      </a:solidFill>
+                      <a:prstDash val="solid"/>
+                      <a:round/>
+                      <a:headEnd type="none" w="med" len="med"/>
+                      <a:tailEnd type="none" w="med" len="med"/>
+                    </a:lnT>
+                    <a:lnB w="6350" cap="flat" cmpd="sng" algn="ctr">
+                      <a:solidFill>
+                        <a:srgbClr val="D0D5DD"/>
+                      </a:solidFill>
+                      <a:prstDash val="solid"/>
+                      <a:round/>
+                      <a:headEnd type="none" w="med" len="med"/>
+                      <a:tailEnd type="none" w="med" len="med"/>
+                    </a:lnB>
+                  </a:tcPr>
+                </a:tc>
+                <a:tc>
+                  <a:txBody>
+                    <a:bodyPr/>
+                    <a:lstStyle/>
+                    <a:p>
+                      <a:pPr indent="0" marL="0">
+                        <a:buNone/>
+                      </a:pPr>
+                      <a:r>
+                        <a:rPr lang="en-US" sz="1200" dirty="0">
+                          <a:solidFill>
+                            <a:schemeClr val="tx1"/>
+                          </a:solidFill>
+                        </a:rPr>
+                        <a:t>54.77</a:t>
+                      </a:r>
+                      <a:endParaRPr lang="en-US" sz="1200" dirty="0"/>
+                    </a:p>
+                  </a:txBody>
+                  <a:tcPr marL="91440" marR="91440" marT="45720" marB="45720">
+                    <a:lnL w="6350" cap="flat" cmpd="sng" algn="ctr">
+                      <a:solidFill>
+                        <a:srgbClr val="D0D5DD"/>
+                      </a:solidFill>
+                      <a:prstDash val="solid"/>
+                      <a:round/>
+                      <a:headEnd type="none" w="med" len="med"/>
+                      <a:tailEnd type="none" w="med" len="med"/>
+                    </a:lnL>
+                    <a:lnR w="6350" cap="flat" cmpd="sng" algn="ctr">
+                      <a:solidFill>
+                        <a:srgbClr val="D0D5DD"/>
+                      </a:solidFill>
+                      <a:prstDash val="solid"/>
+                      <a:round/>
+                      <a:headEnd type="none" w="med" len="med"/>
+                      <a:tailEnd type="none" w="med" len="med"/>
+                    </a:lnR>
+                    <a:lnT w="6350" cap="flat" cmpd="sng" algn="ctr">
+                      <a:solidFill>
+                        <a:srgbClr val="D0D5DD"/>
+                      </a:solidFill>
+                      <a:prstDash val="solid"/>
+                      <a:round/>
+                      <a:headEnd type="none" w="med" len="med"/>
+                      <a:tailEnd type="none" w="med" len="med"/>
+                    </a:lnT>
+                    <a:lnB w="6350" cap="flat" cmpd="sng" algn="ctr">
+                      <a:solidFill>
+                        <a:srgbClr val="D0D5DD"/>
+                      </a:solidFill>
+                      <a:prstDash val="solid"/>
+                      <a:round/>
+                      <a:headEnd type="none" w="med" len="med"/>
+                      <a:tailEnd type="none" w="med" len="med"/>
+                    </a:lnB>
+                  </a:tcPr>
+                </a:tc>
+              </a:tr>
+              <a:tr h="329184">
+                <a:tc>
+                  <a:txBody>
+                    <a:bodyPr/>
+                    <a:lstStyle/>
+                    <a:p>
+                      <a:pPr indent="0" marL="0">
+                        <a:buNone/>
+                      </a:pPr>
+                      <a:r>
+                        <a:rPr lang="en-US" sz="1200" dirty="0">
+                          <a:solidFill>
+                            <a:schemeClr val="tx1"/>
+                          </a:solidFill>
+                        </a:rPr>
+                        <a:t>Extra Trees</a:t>
+                      </a:r>
+                      <a:endParaRPr lang="en-US" sz="1200" dirty="0"/>
+                    </a:p>
+                  </a:txBody>
+                  <a:tcPr marL="91440" marR="91440" marT="45720" marB="45720">
+                    <a:lnL w="6350" cap="flat" cmpd="sng" algn="ctr">
+                      <a:solidFill>
+                        <a:srgbClr val="D0D5DD"/>
+                      </a:solidFill>
+                      <a:prstDash val="solid"/>
+                      <a:round/>
+                      <a:headEnd type="none" w="med" len="med"/>
+                      <a:tailEnd type="none" w="med" len="med"/>
+                    </a:lnL>
+                    <a:lnR w="6350" cap="flat" cmpd="sng" algn="ctr">
+                      <a:solidFill>
+                        <a:srgbClr val="D0D5DD"/>
+                      </a:solidFill>
+                      <a:prstDash val="solid"/>
+                      <a:round/>
+                      <a:headEnd type="none" w="med" len="med"/>
+                      <a:tailEnd type="none" w="med" len="med"/>
+                    </a:lnR>
+                    <a:lnT w="6350" cap="flat" cmpd="sng" algn="ctr">
+                      <a:solidFill>
+                        <a:srgbClr val="D0D5DD"/>
+                      </a:solidFill>
+                      <a:prstDash val="solid"/>
+                      <a:round/>
+                      <a:headEnd type="none" w="med" len="med"/>
+                      <a:tailEnd type="none" w="med" len="med"/>
+                    </a:lnT>
+                    <a:lnB w="6350" cap="flat" cmpd="sng" algn="ctr">
+                      <a:solidFill>
+                        <a:srgbClr val="D0D5DD"/>
+                      </a:solidFill>
+                      <a:prstDash val="solid"/>
+                      <a:round/>
+                      <a:headEnd type="none" w="med" len="med"/>
+                      <a:tailEnd type="none" w="med" len="med"/>
+                    </a:lnB>
+                  </a:tcPr>
+                </a:tc>
+                <a:tc>
+                  <a:txBody>
+                    <a:bodyPr/>
+                    <a:lstStyle/>
+                    <a:p>
+                      <a:pPr indent="0" marL="0">
+                        <a:buNone/>
+                      </a:pPr>
+                      <a:r>
+                        <a:rPr lang="en-US" sz="1200" dirty="0">
+                          <a:solidFill>
+                            <a:schemeClr val="tx1"/>
+                          </a:solidFill>
+                        </a:rPr>
+                        <a:t>122</a:t>
+                      </a:r>
+                      <a:endParaRPr lang="en-US" sz="1200" dirty="0"/>
+                    </a:p>
+                  </a:txBody>
+                  <a:tcPr marL="91440" marR="91440" marT="45720" marB="45720">
+                    <a:lnL w="6350" cap="flat" cmpd="sng" algn="ctr">
+                      <a:solidFill>
+                        <a:srgbClr val="D0D5DD"/>
+                      </a:solidFill>
+                      <a:prstDash val="solid"/>
+                      <a:round/>
+                      <a:headEnd type="none" w="med" len="med"/>
+                      <a:tailEnd type="none" w="med" len="med"/>
+                    </a:lnL>
+                    <a:lnR w="6350" cap="flat" cmpd="sng" algn="ctr">
+                      <a:solidFill>
+                        <a:srgbClr val="D0D5DD"/>
+                      </a:solidFill>
+                      <a:prstDash val="solid"/>
+                      <a:round/>
+                      <a:headEnd type="none" w="med" len="med"/>
+                      <a:tailEnd type="none" w="med" len="med"/>
+                    </a:lnR>
+                    <a:lnT w="6350" cap="flat" cmpd="sng" algn="ctr">
+                      <a:solidFill>
+                        <a:srgbClr val="D0D5DD"/>
+                      </a:solidFill>
+                      <a:prstDash val="solid"/>
+                      <a:round/>
+                      <a:headEnd type="none" w="med" len="med"/>
+                      <a:tailEnd type="none" w="med" len="med"/>
+                    </a:lnT>
+                    <a:lnB w="6350" cap="flat" cmpd="sng" algn="ctr">
+                      <a:solidFill>
+                        <a:srgbClr val="D0D5DD"/>
+                      </a:solidFill>
+                      <a:prstDash val="solid"/>
+                      <a:round/>
+                      <a:headEnd type="none" w="med" len="med"/>
+                      <a:tailEnd type="none" w="med" len="med"/>
+                    </a:lnB>
+                  </a:tcPr>
+                </a:tc>
+                <a:tc>
+                  <a:txBody>
+                    <a:bodyPr/>
+                    <a:lstStyle/>
+                    <a:p>
+                      <a:pPr indent="0" marL="0">
+                        <a:buNone/>
+                      </a:pPr>
+                      <a:r>
+                        <a:rPr lang="en-US" sz="1200" dirty="0">
+                          <a:solidFill>
+                            <a:schemeClr val="tx1"/>
+                          </a:solidFill>
+                        </a:rPr>
+                        <a:t>50.62</a:t>
+                      </a:r>
+                      <a:endParaRPr lang="en-US" sz="1200" dirty="0"/>
+                    </a:p>
+                  </a:txBody>
+                  <a:tcPr marL="91440" marR="91440" marT="45720" marB="45720">
+                    <a:lnL w="6350" cap="flat" cmpd="sng" algn="ctr">
+                      <a:solidFill>
+                        <a:srgbClr val="D0D5DD"/>
+                      </a:solidFill>
+                      <a:prstDash val="solid"/>
+                      <a:round/>
+                      <a:headEnd type="none" w="med" len="med"/>
+                      <a:tailEnd type="none" w="med" len="med"/>
+                    </a:lnL>
+                    <a:lnR w="6350" cap="flat" cmpd="sng" algn="ctr">
+                      <a:solidFill>
+                        <a:srgbClr val="D0D5DD"/>
+                      </a:solidFill>
+                      <a:prstDash val="solid"/>
+                      <a:round/>
+                      <a:headEnd type="none" w="med" len="med"/>
+                      <a:tailEnd type="none" w="med" len="med"/>
+                    </a:lnR>
+                    <a:lnT w="6350" cap="flat" cmpd="sng" algn="ctr">
+                      <a:solidFill>
+                        <a:srgbClr val="D0D5DD"/>
+                      </a:solidFill>
+                      <a:prstDash val="solid"/>
+                      <a:round/>
+                      <a:headEnd type="none" w="med" len="med"/>
+                      <a:tailEnd type="none" w="med" len="med"/>
+                    </a:lnT>
+                    <a:lnB w="6350" cap="flat" cmpd="sng" algn="ctr">
+                      <a:solidFill>
+                        <a:srgbClr val="D0D5DD"/>
+                      </a:solidFill>
+                      <a:prstDash val="solid"/>
+                      <a:round/>
+                      <a:headEnd type="none" w="med" len="med"/>
+                      <a:tailEnd type="none" w="med" len="med"/>
+                    </a:lnB>
+                  </a:tcPr>
+                </a:tc>
+                <a:tc>
+                  <a:txBody>
+                    <a:bodyPr/>
+                    <a:lstStyle/>
+                    <a:p>
+                      <a:pPr indent="0" marL="0">
+                        <a:buNone/>
+                      </a:pPr>
+                      <a:r>
+                        <a:rPr lang="en-US" sz="1200" dirty="0">
+                          <a:solidFill>
+                            <a:schemeClr val="tx1"/>
+                          </a:solidFill>
+                        </a:rPr>
+                        <a:t>124</a:t>
+                      </a:r>
+                      <a:endParaRPr lang="en-US" sz="1200" dirty="0"/>
+                    </a:p>
+                  </a:txBody>
+                  <a:tcPr marL="91440" marR="91440" marT="45720" marB="45720">
+                    <a:lnL w="6350" cap="flat" cmpd="sng" algn="ctr">
+                      <a:solidFill>
+                        <a:srgbClr val="D0D5DD"/>
+                      </a:solidFill>
+                      <a:prstDash val="solid"/>
+                      <a:round/>
+                      <a:headEnd type="none" w="med" len="med"/>
+                      <a:tailEnd type="none" w="med" len="med"/>
+                    </a:lnL>
+                    <a:lnR w="6350" cap="flat" cmpd="sng" algn="ctr">
+                      <a:solidFill>
+                        <a:srgbClr val="D0D5DD"/>
+                      </a:solidFill>
+                      <a:prstDash val="solid"/>
+                      <a:round/>
+                      <a:headEnd type="none" w="med" len="med"/>
+                      <a:tailEnd type="none" w="med" len="med"/>
+                    </a:lnR>
+                    <a:lnT w="6350" cap="flat" cmpd="sng" algn="ctr">
+                      <a:solidFill>
+                        <a:srgbClr val="D0D5DD"/>
+                      </a:solidFill>
+                      <a:prstDash val="solid"/>
+                      <a:round/>
+                      <a:headEnd type="none" w="med" len="med"/>
+                      <a:tailEnd type="none" w="med" len="med"/>
+                    </a:lnT>
+                    <a:lnB w="6350" cap="flat" cmpd="sng" algn="ctr">
+                      <a:solidFill>
+                        <a:srgbClr val="D0D5DD"/>
+                      </a:solidFill>
+                      <a:prstDash val="solid"/>
+                      <a:round/>
+                      <a:headEnd type="none" w="med" len="med"/>
+                      <a:tailEnd type="none" w="med" len="med"/>
+                    </a:lnB>
+                  </a:tcPr>
+                </a:tc>
+                <a:tc>
+                  <a:txBody>
+                    <a:bodyPr/>
+                    <a:lstStyle/>
+                    <a:p>
+                      <a:pPr indent="0" marL="0">
+                        <a:buNone/>
+                      </a:pPr>
+                      <a:r>
+                        <a:rPr lang="en-US" sz="1200" dirty="0">
+                          <a:solidFill>
+                            <a:schemeClr val="tx1"/>
+                          </a:solidFill>
+                        </a:rPr>
+                        <a:t>51.45</a:t>
+                      </a:r>
+                      <a:endParaRPr lang="en-US" sz="1200" dirty="0"/>
+                    </a:p>
+                  </a:txBody>
+                  <a:tcPr marL="91440" marR="91440" marT="45720" marB="45720">
+                    <a:lnL w="6350" cap="flat" cmpd="sng" algn="ctr">
+                      <a:solidFill>
+                        <a:srgbClr val="D0D5DD"/>
+                      </a:solidFill>
+                      <a:prstDash val="solid"/>
+                      <a:round/>
+                      <a:headEnd type="none" w="med" len="med"/>
+                      <a:tailEnd type="none" w="med" len="med"/>
+                    </a:lnL>
+                    <a:lnR w="6350" cap="flat" cmpd="sng" algn="ctr">
+                      <a:solidFill>
+                        <a:srgbClr val="D0D5DD"/>
+                      </a:solidFill>
+                      <a:prstDash val="solid"/>
+                      <a:round/>
+                      <a:headEnd type="none" w="med" len="med"/>
+                      <a:tailEnd type="none" w="med" len="med"/>
+                    </a:lnR>
+                    <a:lnT w="6350" cap="flat" cmpd="sng" algn="ctr">
+                      <a:solidFill>
+                        <a:srgbClr val="D0D5DD"/>
+                      </a:solidFill>
+                      <a:prstDash val="solid"/>
+                      <a:round/>
+                      <a:headEnd type="none" w="med" len="med"/>
+                      <a:tailEnd type="none" w="med" len="med"/>
+                    </a:lnT>
+                    <a:lnB w="6350" cap="flat" cmpd="sng" algn="ctr">
+                      <a:solidFill>
+                        <a:srgbClr val="D0D5DD"/>
+                      </a:solidFill>
+                      <a:prstDash val="solid"/>
+                      <a:round/>
+                      <a:headEnd type="none" w="med" len="med"/>
+                      <a:tailEnd type="none" w="med" len="med"/>
+                    </a:lnB>
+                  </a:tcPr>
+                </a:tc>
+              </a:tr>
+              <a:tr h="329184">
+                <a:tc>
+                  <a:txBody>
+                    <a:bodyPr/>
+                    <a:lstStyle/>
+                    <a:p>
+                      <a:pPr indent="0" marL="0">
+                        <a:buNone/>
+                      </a:pPr>
+                      <a:r>
+                        <a:rPr lang="en-US" sz="1200" dirty="0">
+                          <a:solidFill>
+                            <a:schemeClr val="tx1"/>
+                          </a:solidFill>
+                        </a:rPr>
+                        <a:t>Hist. Gradient Boosting</a:t>
+                      </a:r>
+                      <a:endParaRPr lang="en-US" sz="1200" dirty="0"/>
+                    </a:p>
+                  </a:txBody>
+                  <a:tcPr marL="91440" marR="91440" marT="45720" marB="45720">
+                    <a:lnL w="6350" cap="flat" cmpd="sng" algn="ctr">
+                      <a:solidFill>
+                        <a:srgbClr val="D0D5DD"/>
+                      </a:solidFill>
+                      <a:prstDash val="solid"/>
+                      <a:round/>
+                      <a:headEnd type="none" w="med" len="med"/>
+                      <a:tailEnd type="none" w="med" len="med"/>
+                    </a:lnL>
+                    <a:lnR w="6350" cap="flat" cmpd="sng" algn="ctr">
+                      <a:solidFill>
+                        <a:srgbClr val="D0D5DD"/>
+                      </a:solidFill>
+                      <a:prstDash val="solid"/>
+                      <a:round/>
+                      <a:headEnd type="none" w="med" len="med"/>
+                      <a:tailEnd type="none" w="med" len="med"/>
+                    </a:lnR>
+                    <a:lnT w="6350" cap="flat" cmpd="sng" algn="ctr">
+                      <a:solidFill>
+                        <a:srgbClr val="D0D5DD"/>
+                      </a:solidFill>
+                      <a:prstDash val="solid"/>
+                      <a:round/>
+                      <a:headEnd type="none" w="med" len="med"/>
+                      <a:tailEnd type="none" w="med" len="med"/>
+                    </a:lnT>
+                    <a:lnB w="6350" cap="flat" cmpd="sng" algn="ctr">
+                      <a:solidFill>
+                        <a:srgbClr val="D0D5DD"/>
+                      </a:solidFill>
+                      <a:prstDash val="solid"/>
+                      <a:round/>
+                      <a:headEnd type="none" w="med" len="med"/>
+                      <a:tailEnd type="none" w="med" len="med"/>
+                    </a:lnB>
+                  </a:tcPr>
+                </a:tc>
+                <a:tc>
+                  <a:txBody>
+                    <a:bodyPr/>
+                    <a:lstStyle/>
+                    <a:p>
+                      <a:pPr indent="0" marL="0">
+                        <a:buNone/>
+                      </a:pPr>
+                      <a:r>
+                        <a:rPr lang="en-US" sz="1200" dirty="0">
+                          <a:solidFill>
+                            <a:schemeClr val="tx1"/>
+                          </a:solidFill>
+                        </a:rPr>
+                        <a:t>121</a:t>
+                      </a:r>
+                      <a:endParaRPr lang="en-US" sz="1200" dirty="0"/>
+                    </a:p>
+                  </a:txBody>
+                  <a:tcPr marL="91440" marR="91440" marT="45720" marB="45720">
+                    <a:lnL w="6350" cap="flat" cmpd="sng" algn="ctr">
+                      <a:solidFill>
+                        <a:srgbClr val="D0D5DD"/>
+                      </a:solidFill>
+                      <a:prstDash val="solid"/>
+                      <a:round/>
+                      <a:headEnd type="none" w="med" len="med"/>
+                      <a:tailEnd type="none" w="med" len="med"/>
+                    </a:lnL>
+                    <a:lnR w="6350" cap="flat" cmpd="sng" algn="ctr">
+                      <a:solidFill>
+                        <a:srgbClr val="D0D5DD"/>
+                      </a:solidFill>
+                      <a:prstDash val="solid"/>
+                      <a:round/>
+                      <a:headEnd type="none" w="med" len="med"/>
+                      <a:tailEnd type="none" w="med" len="med"/>
+                    </a:lnR>
+                    <a:lnT w="6350" cap="flat" cmpd="sng" algn="ctr">
+                      <a:solidFill>
+                        <a:srgbClr val="D0D5DD"/>
+                      </a:solidFill>
+                      <a:prstDash val="solid"/>
+                      <a:round/>
+                      <a:headEnd type="none" w="med" len="med"/>
+                      <a:tailEnd type="none" w="med" len="med"/>
+                    </a:lnT>
+                    <a:lnB w="6350" cap="flat" cmpd="sng" algn="ctr">
+                      <a:solidFill>
+                        <a:srgbClr val="D0D5DD"/>
+                      </a:solidFill>
+                      <a:prstDash val="solid"/>
+                      <a:round/>
+                      <a:headEnd type="none" w="med" len="med"/>
+                      <a:tailEnd type="none" w="med" len="med"/>
+                    </a:lnB>
+                  </a:tcPr>
+                </a:tc>
+                <a:tc>
+                  <a:txBody>
+                    <a:bodyPr/>
+                    <a:lstStyle/>
+                    <a:p>
+                      <a:pPr indent="0" marL="0">
+                        <a:buNone/>
+                      </a:pPr>
+                      <a:r>
+                        <a:rPr lang="en-US" sz="1200" dirty="0">
+                          <a:solidFill>
+                            <a:schemeClr val="tx1"/>
+                          </a:solidFill>
+                        </a:rPr>
+                        <a:t>50.21</a:t>
+                      </a:r>
+                      <a:endParaRPr lang="en-US" sz="1200" dirty="0"/>
+                    </a:p>
+                  </a:txBody>
+                  <a:tcPr marL="91440" marR="91440" marT="45720" marB="45720">
+                    <a:lnL w="6350" cap="flat" cmpd="sng" algn="ctr">
+                      <a:solidFill>
+                        <a:srgbClr val="D0D5DD"/>
+                      </a:solidFill>
+                      <a:prstDash val="solid"/>
+                      <a:round/>
+                      <a:headEnd type="none" w="med" len="med"/>
+                      <a:tailEnd type="none" w="med" len="med"/>
+                    </a:lnL>
+                    <a:lnR w="6350" cap="flat" cmpd="sng" algn="ctr">
+                      <a:solidFill>
+                        <a:srgbClr val="D0D5DD"/>
+                      </a:solidFill>
+                      <a:prstDash val="solid"/>
+                      <a:round/>
+                      <a:headEnd type="none" w="med" len="med"/>
+                      <a:tailEnd type="none" w="med" len="med"/>
+                    </a:lnR>
+                    <a:lnT w="6350" cap="flat" cmpd="sng" algn="ctr">
+                      <a:solidFill>
+                        <a:srgbClr val="D0D5DD"/>
+                      </a:solidFill>
+                      <a:prstDash val="solid"/>
+                      <a:round/>
+                      <a:headEnd type="none" w="med" len="med"/>
+                      <a:tailEnd type="none" w="med" len="med"/>
+                    </a:lnT>
+                    <a:lnB w="6350" cap="flat" cmpd="sng" algn="ctr">
+                      <a:solidFill>
+                        <a:srgbClr val="D0D5DD"/>
+                      </a:solidFill>
+                      <a:prstDash val="solid"/>
+                      <a:round/>
+                      <a:headEnd type="none" w="med" len="med"/>
+                      <a:tailEnd type="none" w="med" len="med"/>
+                    </a:lnB>
+                  </a:tcPr>
+                </a:tc>
+                <a:tc>
+                  <a:txBody>
+                    <a:bodyPr/>
+                    <a:lstStyle/>
+                    <a:p>
+                      <a:pPr indent="0" marL="0">
+                        <a:buNone/>
+                      </a:pPr>
+                      <a:r>
+                        <a:rPr lang="en-US" sz="1200" dirty="0">
+                          <a:solidFill>
+                            <a:schemeClr val="tx1"/>
+                          </a:solidFill>
+                        </a:rPr>
+                        <a:t>128</a:t>
+                      </a:r>
+                      <a:endParaRPr lang="en-US" sz="1200" dirty="0"/>
+                    </a:p>
+                  </a:txBody>
+                  <a:tcPr marL="91440" marR="91440" marT="45720" marB="45720">
+                    <a:lnL w="6350" cap="flat" cmpd="sng" algn="ctr">
+                      <a:solidFill>
+                        <a:srgbClr val="D0D5DD"/>
+                      </a:solidFill>
+                      <a:prstDash val="solid"/>
+                      <a:round/>
+                      <a:headEnd type="none" w="med" len="med"/>
+                      <a:tailEnd type="none" w="med" len="med"/>
+                    </a:lnL>
+                    <a:lnR w="6350" cap="flat" cmpd="sng" algn="ctr">
+                      <a:solidFill>
+                        <a:srgbClr val="D0D5DD"/>
+                      </a:solidFill>
+                      <a:prstDash val="solid"/>
+                      <a:round/>
+                      <a:headEnd type="none" w="med" len="med"/>
+                      <a:tailEnd type="none" w="med" len="med"/>
+                    </a:lnR>
+                    <a:lnT w="6350" cap="flat" cmpd="sng" algn="ctr">
+                      <a:solidFill>
+                        <a:srgbClr val="D0D5DD"/>
+                      </a:solidFill>
+                      <a:prstDash val="solid"/>
+                      <a:round/>
+                      <a:headEnd type="none" w="med" len="med"/>
+                      <a:tailEnd type="none" w="med" len="med"/>
+                    </a:lnT>
+                    <a:lnB w="6350" cap="flat" cmpd="sng" algn="ctr">
+                      <a:solidFill>
+                        <a:srgbClr val="D0D5DD"/>
+                      </a:solidFill>
+                      <a:prstDash val="solid"/>
+                      <a:round/>
+                      <a:headEnd type="none" w="med" len="med"/>
+                      <a:tailEnd type="none" w="med" len="med"/>
+                    </a:lnB>
+                  </a:tcPr>
+                </a:tc>
+                <a:tc>
+                  <a:txBody>
+                    <a:bodyPr/>
+                    <a:lstStyle/>
+                    <a:p>
+                      <a:pPr indent="0" marL="0">
+                        <a:buNone/>
+                      </a:pPr>
+                      <a:r>
+                        <a:rPr lang="en-US" sz="1200" dirty="0">
+                          <a:solidFill>
+                            <a:schemeClr val="tx1"/>
+                          </a:solidFill>
+                        </a:rPr>
+                        <a:t>53.11</a:t>
+                      </a:r>
+                      <a:endParaRPr lang="en-US" sz="1200" dirty="0"/>
+                    </a:p>
+                  </a:txBody>
+                  <a:tcPr marL="91440" marR="91440" marT="45720" marB="45720">
+                    <a:lnL w="6350" cap="flat" cmpd="sng" algn="ctr">
+                      <a:solidFill>
+                        <a:srgbClr val="D0D5DD"/>
+                      </a:solidFill>
+                      <a:prstDash val="solid"/>
+                      <a:round/>
+                      <a:headEnd type="none" w="med" len="med"/>
+                      <a:tailEnd type="none" w="med" len="med"/>
+                    </a:lnL>
+                    <a:lnR w="6350" cap="flat" cmpd="sng" algn="ctr">
+                      <a:solidFill>
+                        <a:srgbClr val="D0D5DD"/>
+                      </a:solidFill>
+                      <a:prstDash val="solid"/>
+                      <a:round/>
+                      <a:headEnd type="none" w="med" len="med"/>
+                      <a:tailEnd type="none" w="med" len="med"/>
+                    </a:lnR>
+                    <a:lnT w="6350" cap="flat" cmpd="sng" algn="ctr">
+                      <a:solidFill>
+                        <a:srgbClr val="D0D5DD"/>
+                      </a:solidFill>
+                      <a:prstDash val="solid"/>
+                      <a:round/>
+                      <a:headEnd type="none" w="med" len="med"/>
+                      <a:tailEnd type="none" w="med" len="med"/>
+                    </a:lnT>
+                    <a:lnB w="6350" cap="flat" cmpd="sng" algn="ctr">
+                      <a:solidFill>
+                        <a:srgbClr val="D0D5DD"/>
+                      </a:solidFill>
+                      <a:prstDash val="solid"/>
+                      <a:round/>
+                      <a:headEnd type="none" w="med" len="med"/>
+                      <a:tailEnd type="none" w="med" len="med"/>
+                    </a:lnB>
+                  </a:tcPr>
+                </a:tc>
+              </a:tr>
+              <a:tr h="329184">
+                <a:tc>
+                  <a:txBody>
+                    <a:bodyPr/>
+                    <a:lstStyle/>
+                    <a:p>
+                      <a:pPr indent="0" marL="0">
+                        <a:buNone/>
+                      </a:pPr>
+                      <a:r>
+                        <a:rPr lang="en-US" sz="1200" dirty="0">
+                          <a:solidFill>
+                            <a:schemeClr val="tx1"/>
+                          </a:solidFill>
+                        </a:rPr>
+                        <a:t>AdaBoost</a:t>
+                      </a:r>
+                      <a:endParaRPr lang="en-US" sz="1200" dirty="0"/>
+                    </a:p>
+                  </a:txBody>
+                  <a:tcPr marL="91440" marR="91440" marT="45720" marB="45720">
+                    <a:lnL w="6350" cap="flat" cmpd="sng" algn="ctr">
+                      <a:solidFill>
+                        <a:srgbClr val="D0D5DD"/>
+                      </a:solidFill>
+                      <a:prstDash val="solid"/>
+                      <a:round/>
+                      <a:headEnd type="none" w="med" len="med"/>
+                      <a:tailEnd type="none" w="med" len="med"/>
+                    </a:lnL>
+                    <a:lnR w="6350" cap="flat" cmpd="sng" algn="ctr">
+                      <a:solidFill>
+                        <a:srgbClr val="D0D5DD"/>
+                      </a:solidFill>
+                      <a:prstDash val="solid"/>
+                      <a:round/>
+                      <a:headEnd type="none" w="med" len="med"/>
+                      <a:tailEnd type="none" w="med" len="med"/>
+                    </a:lnR>
+                    <a:lnT w="6350" cap="flat" cmpd="sng" algn="ctr">
+                      <a:solidFill>
+                        <a:srgbClr val="D0D5DD"/>
+                      </a:solidFill>
+                      <a:prstDash val="solid"/>
+                      <a:round/>
+                      <a:headEnd type="none" w="med" len="med"/>
+                      <a:tailEnd type="none" w="med" len="med"/>
+                    </a:lnT>
+                    <a:lnB w="6350" cap="flat" cmpd="sng" algn="ctr">
+                      <a:solidFill>
+                        <a:srgbClr val="D0D5DD"/>
+                      </a:solidFill>
+                      <a:prstDash val="solid"/>
+                      <a:round/>
+                      <a:headEnd type="none" w="med" len="med"/>
+                      <a:tailEnd type="none" w="med" len="med"/>
+                    </a:lnB>
+                  </a:tcPr>
+                </a:tc>
+                <a:tc>
+                  <a:txBody>
+                    <a:bodyPr/>
+                    <a:lstStyle/>
+                    <a:p>
+                      <a:pPr indent="0" marL="0">
+                        <a:buNone/>
+                      </a:pPr>
+                      <a:r>
+                        <a:rPr lang="en-US" sz="1200" dirty="0">
+                          <a:solidFill>
+                            <a:schemeClr val="tx1"/>
+                          </a:solidFill>
+                        </a:rPr>
+                        <a:t>117</a:t>
+                      </a:r>
+                      <a:endParaRPr lang="en-US" sz="1200" dirty="0"/>
+                    </a:p>
+                  </a:txBody>
+                  <a:tcPr marL="91440" marR="91440" marT="45720" marB="45720">
+                    <a:lnL w="6350" cap="flat" cmpd="sng" algn="ctr">
+                      <a:solidFill>
+                        <a:srgbClr val="D0D5DD"/>
+                      </a:solidFill>
+                      <a:prstDash val="solid"/>
+                      <a:round/>
+                      <a:headEnd type="none" w="med" len="med"/>
+                      <a:tailEnd type="none" w="med" len="med"/>
+                    </a:lnL>
+                    <a:lnR w="6350" cap="flat" cmpd="sng" algn="ctr">
+                      <a:solidFill>
+                        <a:srgbClr val="D0D5DD"/>
+                      </a:solidFill>
+                      <a:prstDash val="solid"/>
+                      <a:round/>
+                      <a:headEnd type="none" w="med" len="med"/>
+                      <a:tailEnd type="none" w="med" len="med"/>
+                    </a:lnR>
+                    <a:lnT w="6350" cap="flat" cmpd="sng" algn="ctr">
+                      <a:solidFill>
+                        <a:srgbClr val="D0D5DD"/>
+                      </a:solidFill>
+                      <a:prstDash val="solid"/>
+                      <a:round/>
+                      <a:headEnd type="none" w="med" len="med"/>
+                      <a:tailEnd type="none" w="med" len="med"/>
+                    </a:lnT>
+                    <a:lnB w="6350" cap="flat" cmpd="sng" algn="ctr">
+                      <a:solidFill>
+                        <a:srgbClr val="D0D5DD"/>
+                      </a:solidFill>
+                      <a:prstDash val="solid"/>
+                      <a:round/>
+                      <a:headEnd type="none" w="med" len="med"/>
+                      <a:tailEnd type="none" w="med" len="med"/>
+                    </a:lnB>
+                  </a:tcPr>
+                </a:tc>
+                <a:tc>
+                  <a:txBody>
+                    <a:bodyPr/>
+                    <a:lstStyle/>
+                    <a:p>
+                      <a:pPr indent="0" marL="0">
+                        <a:buNone/>
+                      </a:pPr>
+                      <a:r>
+                        <a:rPr lang="en-US" sz="1200" dirty="0">
+                          <a:solidFill>
+                            <a:schemeClr val="tx1"/>
+                          </a:solidFill>
+                        </a:rPr>
+                        <a:t>48.55</a:t>
+                      </a:r>
+                      <a:endParaRPr lang="en-US" sz="1200" dirty="0"/>
+                    </a:p>
+                  </a:txBody>
+                  <a:tcPr marL="91440" marR="91440" marT="45720" marB="45720">
+                    <a:lnL w="6350" cap="flat" cmpd="sng" algn="ctr">
+                      <a:solidFill>
+                        <a:srgbClr val="D0D5DD"/>
+                      </a:solidFill>
+                      <a:prstDash val="solid"/>
+                      <a:round/>
+                      <a:headEnd type="none" w="med" len="med"/>
+                      <a:tailEnd type="none" w="med" len="med"/>
+                    </a:lnL>
+                    <a:lnR w="6350" cap="flat" cmpd="sng" algn="ctr">
+                      <a:solidFill>
+                        <a:srgbClr val="D0D5DD"/>
+                      </a:solidFill>
+                      <a:prstDash val="solid"/>
+                      <a:round/>
+                      <a:headEnd type="none" w="med" len="med"/>
+                      <a:tailEnd type="none" w="med" len="med"/>
+                    </a:lnR>
+                    <a:lnT w="6350" cap="flat" cmpd="sng" algn="ctr">
+                      <a:solidFill>
+                        <a:srgbClr val="D0D5DD"/>
+                      </a:solidFill>
+                      <a:prstDash val="solid"/>
+                      <a:round/>
+                      <a:headEnd type="none" w="med" len="med"/>
+                      <a:tailEnd type="none" w="med" len="med"/>
+                    </a:lnT>
+                    <a:lnB w="6350" cap="flat" cmpd="sng" algn="ctr">
+                      <a:solidFill>
+                        <a:srgbClr val="D0D5DD"/>
+                      </a:solidFill>
+                      <a:prstDash val="solid"/>
+                      <a:round/>
+                      <a:headEnd type="none" w="med" len="med"/>
+                      <a:tailEnd type="none" w="med" len="med"/>
+                    </a:lnB>
+                  </a:tcPr>
+                </a:tc>
+                <a:tc>
+                  <a:txBody>
+                    <a:bodyPr/>
+                    <a:lstStyle/>
+                    <a:p>
+                      <a:pPr indent="0" marL="0">
+                        <a:buNone/>
+                      </a:pPr>
+                      <a:r>
+                        <a:rPr lang="en-US" sz="1200" dirty="0">
+                          <a:solidFill>
+                            <a:schemeClr val="tx1"/>
+                          </a:solidFill>
+                        </a:rPr>
+                        <a:t>131</a:t>
+                      </a:r>
+                      <a:endParaRPr lang="en-US" sz="1200" dirty="0"/>
+                    </a:p>
+                  </a:txBody>
+                  <a:tcPr marL="91440" marR="91440" marT="45720" marB="45720">
+                    <a:lnL w="6350" cap="flat" cmpd="sng" algn="ctr">
+                      <a:solidFill>
+                        <a:srgbClr val="D0D5DD"/>
+                      </a:solidFill>
+                      <a:prstDash val="solid"/>
+                      <a:round/>
+                      <a:headEnd type="none" w="med" len="med"/>
+                      <a:tailEnd type="none" w="med" len="med"/>
+                    </a:lnL>
+                    <a:lnR w="6350" cap="flat" cmpd="sng" algn="ctr">
+                      <a:solidFill>
+                        <a:srgbClr val="D0D5DD"/>
+                      </a:solidFill>
+                      <a:prstDash val="solid"/>
+                      <a:round/>
+                      <a:headEnd type="none" w="med" len="med"/>
+                      <a:tailEnd type="none" w="med" len="med"/>
+                    </a:lnR>
+                    <a:lnT w="6350" cap="flat" cmpd="sng" algn="ctr">
+                      <a:solidFill>
+                        <a:srgbClr val="D0D5DD"/>
+                      </a:solidFill>
+                      <a:prstDash val="solid"/>
+                      <a:round/>
+                      <a:headEnd type="none" w="med" len="med"/>
+                      <a:tailEnd type="none" w="med" len="med"/>
+                    </a:lnT>
+                    <a:lnB w="6350" cap="flat" cmpd="sng" algn="ctr">
+                      <a:solidFill>
+                        <a:srgbClr val="D0D5DD"/>
+                      </a:solidFill>
+                      <a:prstDash val="solid"/>
+                      <a:round/>
+                      <a:headEnd type="none" w="med" len="med"/>
+                      <a:tailEnd type="none" w="med" len="med"/>
+                    </a:lnB>
+                  </a:tcPr>
+                </a:tc>
+                <a:tc>
+                  <a:txBody>
+                    <a:bodyPr/>
+                    <a:lstStyle/>
+                    <a:p>
+                      <a:pPr indent="0" marL="0">
+                        <a:buNone/>
+                      </a:pPr>
+                      <a:r>
+                        <a:rPr lang="en-US" sz="1200" dirty="0">
+                          <a:solidFill>
+                            <a:schemeClr val="tx1"/>
+                          </a:solidFill>
+                        </a:rPr>
+                        <a:t>54.36</a:t>
+                      </a:r>
+                      <a:endParaRPr lang="en-US" sz="1200" dirty="0"/>
+                    </a:p>
+                  </a:txBody>
+                  <a:tcPr marL="91440" marR="91440" marT="45720" marB="45720">
+                    <a:lnL w="6350" cap="flat" cmpd="sng" algn="ctr">
+                      <a:solidFill>
+                        <a:srgbClr val="D0D5DD"/>
+                      </a:solidFill>
+                      <a:prstDash val="solid"/>
+                      <a:round/>
+                      <a:headEnd type="none" w="med" len="med"/>
+                      <a:tailEnd type="none" w="med" len="med"/>
+                    </a:lnL>
+                    <a:lnR w="6350" cap="flat" cmpd="sng" algn="ctr">
+                      <a:solidFill>
+                        <a:srgbClr val="D0D5DD"/>
+                      </a:solidFill>
+                      <a:prstDash val="solid"/>
+                      <a:round/>
+                      <a:headEnd type="none" w="med" len="med"/>
+                      <a:tailEnd type="none" w="med" len="med"/>
+                    </a:lnR>
+                    <a:lnT w="6350" cap="flat" cmpd="sng" algn="ctr">
+                      <a:solidFill>
+                        <a:srgbClr val="D0D5DD"/>
+                      </a:solidFill>
+                      <a:prstDash val="solid"/>
+                      <a:round/>
+                      <a:headEnd type="none" w="med" len="med"/>
+                      <a:tailEnd type="none" w="med" len="med"/>
+                    </a:lnT>
+                    <a:lnB w="6350" cap="flat" cmpd="sng" algn="ctr">
+                      <a:solidFill>
+                        <a:srgbClr val="D0D5DD"/>
+                      </a:solidFill>
+                      <a:prstDash val="solid"/>
+                      <a:round/>
+                      <a:headEnd type="none" w="med" len="med"/>
+                      <a:tailEnd type="none" w="med" len="med"/>
+                    </a:lnB>
+                  </a:tcPr>
+                </a:tc>
+              </a:tr>
+              <a:tr h="329184">
+                <a:tc>
+                  <a:txBody>
+                    <a:bodyPr/>
+                    <a:lstStyle/>
+                    <a:p>
+                      <a:pPr indent="0" marL="0">
+                        <a:buNone/>
+                      </a:pPr>
+                      <a:r>
+                        <a:rPr lang="en-US" sz="1200" dirty="0">
+                          <a:solidFill>
+                            <a:schemeClr val="tx1"/>
+                          </a:solidFill>
+                        </a:rPr>
+                        <a:t>Naive Bayes</a:t>
+                      </a:r>
+                      <a:endParaRPr lang="en-US" sz="1200" dirty="0"/>
+                    </a:p>
+                  </a:txBody>
+                  <a:tcPr marL="91440" marR="91440" marT="45720" marB="45720">
+                    <a:lnL w="6350" cap="flat" cmpd="sng" algn="ctr">
+                      <a:solidFill>
+                        <a:srgbClr val="D0D5DD"/>
+                      </a:solidFill>
+                      <a:prstDash val="solid"/>
+                      <a:round/>
+                      <a:headEnd type="none" w="med" len="med"/>
+                      <a:tailEnd type="none" w="med" len="med"/>
+                    </a:lnL>
+                    <a:lnR w="6350" cap="flat" cmpd="sng" algn="ctr">
+                      <a:solidFill>
+                        <a:srgbClr val="D0D5DD"/>
+                      </a:solidFill>
+                      <a:prstDash val="solid"/>
+                      <a:round/>
+                      <a:headEnd type="none" w="med" len="med"/>
+                      <a:tailEnd type="none" w="med" len="med"/>
+                    </a:lnR>
+                    <a:lnT w="6350" cap="flat" cmpd="sng" algn="ctr">
+                      <a:solidFill>
+                        <a:srgbClr val="D0D5DD"/>
+                      </a:solidFill>
+                      <a:prstDash val="solid"/>
+                      <a:round/>
+                      <a:headEnd type="none" w="med" len="med"/>
+                      <a:tailEnd type="none" w="med" len="med"/>
+                    </a:lnT>
+                    <a:lnB w="6350" cap="flat" cmpd="sng" algn="ctr">
+                      <a:solidFill>
+                        <a:srgbClr val="D0D5DD"/>
+                      </a:solidFill>
+                      <a:prstDash val="solid"/>
+                      <a:round/>
+                      <a:headEnd type="none" w="med" len="med"/>
+                      <a:tailEnd type="none" w="med" len="med"/>
+                    </a:lnB>
+                  </a:tcPr>
+                </a:tc>
+                <a:tc>
+                  <a:txBody>
+                    <a:bodyPr/>
+                    <a:lstStyle/>
+                    <a:p>
+                      <a:pPr indent="0" marL="0">
+                        <a:buNone/>
+                      </a:pPr>
+                      <a:r>
+                        <a:rPr lang="en-US" sz="1200" dirty="0">
+                          <a:solidFill>
+                            <a:schemeClr val="tx1"/>
+                          </a:solidFill>
+                        </a:rPr>
+                        <a:t>109</a:t>
+                      </a:r>
+                      <a:endParaRPr lang="en-US" sz="1200" dirty="0"/>
+                    </a:p>
+                  </a:txBody>
+                  <a:tcPr marL="91440" marR="91440" marT="45720" marB="45720">
+                    <a:lnL w="6350" cap="flat" cmpd="sng" algn="ctr">
+                      <a:solidFill>
+                        <a:srgbClr val="D0D5DD"/>
+                      </a:solidFill>
+                      <a:prstDash val="solid"/>
+                      <a:round/>
+                      <a:headEnd type="none" w="med" len="med"/>
+                      <a:tailEnd type="none" w="med" len="med"/>
+                    </a:lnL>
+                    <a:lnR w="6350" cap="flat" cmpd="sng" algn="ctr">
+                      <a:solidFill>
+                        <a:srgbClr val="D0D5DD"/>
+                      </a:solidFill>
+                      <a:prstDash val="solid"/>
+                      <a:round/>
+                      <a:headEnd type="none" w="med" len="med"/>
+                      <a:tailEnd type="none" w="med" len="med"/>
+                    </a:lnR>
+                    <a:lnT w="6350" cap="flat" cmpd="sng" algn="ctr">
+                      <a:solidFill>
+                        <a:srgbClr val="D0D5DD"/>
+                      </a:solidFill>
+                      <a:prstDash val="solid"/>
+                      <a:round/>
+                      <a:headEnd type="none" w="med" len="med"/>
+                      <a:tailEnd type="none" w="med" len="med"/>
+                    </a:lnT>
+                    <a:lnB w="6350" cap="flat" cmpd="sng" algn="ctr">
+                      <a:solidFill>
+                        <a:srgbClr val="D0D5DD"/>
+                      </a:solidFill>
+                      <a:prstDash val="solid"/>
+                      <a:round/>
+                      <a:headEnd type="none" w="med" len="med"/>
+                      <a:tailEnd type="none" w="med" len="med"/>
+                    </a:lnB>
+                  </a:tcPr>
+                </a:tc>
+                <a:tc>
+                  <a:txBody>
+                    <a:bodyPr/>
+                    <a:lstStyle/>
+                    <a:p>
+                      <a:pPr indent="0" marL="0">
+                        <a:buNone/>
+                      </a:pPr>
+                      <a:r>
+                        <a:rPr lang="en-US" sz="1200" dirty="0">
+                          <a:solidFill>
+                            <a:schemeClr val="tx1"/>
+                          </a:solidFill>
+                        </a:rPr>
+                        <a:t>45.23</a:t>
+                      </a:r>
+                      <a:endParaRPr lang="en-US" sz="1200" dirty="0"/>
+                    </a:p>
+                  </a:txBody>
+                  <a:tcPr marL="91440" marR="91440" marT="45720" marB="45720">
+                    <a:lnL w="6350" cap="flat" cmpd="sng" algn="ctr">
+                      <a:solidFill>
+                        <a:srgbClr val="D0D5DD"/>
+                      </a:solidFill>
+                      <a:prstDash val="solid"/>
+                      <a:round/>
+                      <a:headEnd type="none" w="med" len="med"/>
+                      <a:tailEnd type="none" w="med" len="med"/>
+                    </a:lnL>
+                    <a:lnR w="6350" cap="flat" cmpd="sng" algn="ctr">
+                      <a:solidFill>
+                        <a:srgbClr val="D0D5DD"/>
+                      </a:solidFill>
+                      <a:prstDash val="solid"/>
+                      <a:round/>
+                      <a:headEnd type="none" w="med" len="med"/>
+                      <a:tailEnd type="none" w="med" len="med"/>
+                    </a:lnR>
+                    <a:lnT w="6350" cap="flat" cmpd="sng" algn="ctr">
+                      <a:solidFill>
+                        <a:srgbClr val="D0D5DD"/>
+                      </a:solidFill>
+                      <a:prstDash val="solid"/>
+                      <a:round/>
+                      <a:headEnd type="none" w="med" len="med"/>
+                      <a:tailEnd type="none" w="med" len="med"/>
+                    </a:lnT>
+                    <a:lnB w="6350" cap="flat" cmpd="sng" algn="ctr">
+                      <a:solidFill>
+                        <a:srgbClr val="D0D5DD"/>
+                      </a:solidFill>
+                      <a:prstDash val="solid"/>
+                      <a:round/>
+                      <a:headEnd type="none" w="med" len="med"/>
+                      <a:tailEnd type="none" w="med" len="med"/>
+                    </a:lnB>
+                  </a:tcPr>
+                </a:tc>
+                <a:tc>
+                  <a:txBody>
+                    <a:bodyPr/>
+                    <a:lstStyle/>
+                    <a:p>
+                      <a:pPr indent="0" marL="0">
+                        <a:buNone/>
+                      </a:pPr>
+                      <a:r>
+                        <a:rPr lang="en-US" sz="1200" dirty="0">
+                          <a:solidFill>
+                            <a:schemeClr val="tx1"/>
+                          </a:solidFill>
+                        </a:rPr>
+                        <a:t>116</a:t>
+                      </a:r>
+                      <a:endParaRPr lang="en-US" sz="1200" dirty="0"/>
+                    </a:p>
+                  </a:txBody>
+                  <a:tcPr marL="91440" marR="91440" marT="45720" marB="45720">
+                    <a:lnL w="6350" cap="flat" cmpd="sng" algn="ctr">
+                      <a:solidFill>
+                        <a:srgbClr val="D0D5DD"/>
+                      </a:solidFill>
+                      <a:prstDash val="solid"/>
+                      <a:round/>
+                      <a:headEnd type="none" w="med" len="med"/>
+                      <a:tailEnd type="none" w="med" len="med"/>
+                    </a:lnL>
+                    <a:lnR w="6350" cap="flat" cmpd="sng" algn="ctr">
+                      <a:solidFill>
+                        <a:srgbClr val="D0D5DD"/>
+                      </a:solidFill>
+                      <a:prstDash val="solid"/>
+                      <a:round/>
+                      <a:headEnd type="none" w="med" len="med"/>
+                      <a:tailEnd type="none" w="med" len="med"/>
+                    </a:lnR>
+                    <a:lnT w="6350" cap="flat" cmpd="sng" algn="ctr">
+                      <a:solidFill>
+                        <a:srgbClr val="D0D5DD"/>
+                      </a:solidFill>
+                      <a:prstDash val="solid"/>
+                      <a:round/>
+                      <a:headEnd type="none" w="med" len="med"/>
+                      <a:tailEnd type="none" w="med" len="med"/>
+                    </a:lnT>
+                    <a:lnB w="6350" cap="flat" cmpd="sng" algn="ctr">
+                      <a:solidFill>
+                        <a:srgbClr val="D0D5DD"/>
+                      </a:solidFill>
+                      <a:prstDash val="solid"/>
+                      <a:round/>
+                      <a:headEnd type="none" w="med" len="med"/>
+                      <a:tailEnd type="none" w="med" len="med"/>
+                    </a:lnB>
+                  </a:tcPr>
+                </a:tc>
+                <a:tc>
+                  <a:txBody>
+                    <a:bodyPr/>
+                    <a:lstStyle/>
+                    <a:p>
+                      <a:pPr indent="0" marL="0">
+                        <a:buNone/>
+                      </a:pPr>
+                      <a:r>
+                        <a:rPr lang="en-US" sz="1200" dirty="0">
+                          <a:solidFill>
+                            <a:schemeClr val="tx1"/>
+                          </a:solidFill>
+                        </a:rPr>
+                        <a:t>48.13</a:t>
+                      </a:r>
+                      <a:endParaRPr lang="en-US" sz="1200" dirty="0"/>
+                    </a:p>
+                  </a:txBody>
+                  <a:tcPr marL="91440" marR="91440" marT="45720" marB="45720">
+                    <a:lnL w="6350" cap="flat" cmpd="sng" algn="ctr">
+                      <a:solidFill>
+                        <a:srgbClr val="D0D5DD"/>
+                      </a:solidFill>
+                      <a:prstDash val="solid"/>
+                      <a:round/>
+                      <a:headEnd type="none" w="med" len="med"/>
+                      <a:tailEnd type="none" w="med" len="med"/>
+                    </a:lnL>
+                    <a:lnR w="6350" cap="flat" cmpd="sng" algn="ctr">
+                      <a:solidFill>
+                        <a:srgbClr val="D0D5DD"/>
+                      </a:solidFill>
+                      <a:prstDash val="solid"/>
+                      <a:round/>
+                      <a:headEnd type="none" w="med" len="med"/>
+                      <a:tailEnd type="none" w="med" len="med"/>
+                    </a:lnR>
+                    <a:lnT w="6350" cap="flat" cmpd="sng" algn="ctr">
+                      <a:solidFill>
+                        <a:srgbClr val="D0D5DD"/>
+                      </a:solidFill>
+                      <a:prstDash val="solid"/>
+                      <a:round/>
+                      <a:headEnd type="none" w="med" len="med"/>
+                      <a:tailEnd type="none" w="med" len="med"/>
+                    </a:lnT>
+                    <a:lnB w="6350" cap="flat" cmpd="sng" algn="ctr">
+                      <a:solidFill>
+                        <a:srgbClr val="D0D5DD"/>
+                      </a:solidFill>
+                      <a:prstDash val="solid"/>
+                      <a:round/>
+                      <a:headEnd type="none" w="med" len="med"/>
+                      <a:tailEnd type="none" w="med" len="med"/>
+                    </a:lnB>
+                  </a:tcPr>
+                </a:tc>
+              </a:tr>
+              <a:tr h="329184">
+                <a:tc>
+                  <a:txBody>
+                    <a:bodyPr/>
+                    <a:lstStyle/>
+                    <a:p>
+                      <a:pPr indent="0" marL="0">
+                        <a:buNone/>
+                      </a:pPr>
+                      <a:r>
+                        <a:rPr lang="en-US" sz="1200" dirty="0">
+                          <a:solidFill>
+                            <a:schemeClr val="tx1"/>
+                          </a:solidFill>
+                        </a:rPr>
+                        <a:t>Random Forest</a:t>
+                      </a:r>
+                      <a:endParaRPr lang="en-US" sz="1200" dirty="0"/>
+                    </a:p>
+                  </a:txBody>
+                  <a:tcPr marL="91440" marR="91440" marT="45720" marB="45720">
+                    <a:lnL w="6350" cap="flat" cmpd="sng" algn="ctr">
+                      <a:solidFill>
+                        <a:srgbClr val="D0D5DD"/>
+                      </a:solidFill>
+                      <a:prstDash val="solid"/>
+                      <a:round/>
+                      <a:headEnd type="none" w="med" len="med"/>
+                      <a:tailEnd type="none" w="med" len="med"/>
+                    </a:lnL>
+                    <a:lnR w="6350" cap="flat" cmpd="sng" algn="ctr">
+                      <a:solidFill>
+                        <a:srgbClr val="D0D5DD"/>
+                      </a:solidFill>
+                      <a:prstDash val="solid"/>
+                      <a:round/>
+                      <a:headEnd type="none" w="med" len="med"/>
+                      <a:tailEnd type="none" w="med" len="med"/>
+                    </a:lnR>
+                    <a:lnT w="6350" cap="flat" cmpd="sng" algn="ctr">
+                      <a:solidFill>
+                        <a:srgbClr val="D0D5DD"/>
+                      </a:solidFill>
+                      <a:prstDash val="solid"/>
+                      <a:round/>
+                      <a:headEnd type="none" w="med" len="med"/>
+                      <a:tailEnd type="none" w="med" len="med"/>
+                    </a:lnT>
+                    <a:lnB w="6350" cap="flat" cmpd="sng" algn="ctr">
+                      <a:solidFill>
+                        <a:srgbClr val="D0D5DD"/>
+                      </a:solidFill>
+                      <a:prstDash val="solid"/>
+                      <a:round/>
+                      <a:headEnd type="none" w="med" len="med"/>
+                      <a:tailEnd type="none" w="med" len="med"/>
+                    </a:lnB>
+                  </a:tcPr>
+                </a:tc>
+                <a:tc>
+                  <a:txBody>
+                    <a:bodyPr/>
+                    <a:lstStyle/>
+                    <a:p>
+                      <a:pPr indent="0" marL="0">
+                        <a:buNone/>
+                      </a:pPr>
+                      <a:r>
+                        <a:rPr lang="en-US" sz="1200" dirty="0">
+                          <a:solidFill>
+                            <a:schemeClr val="tx1"/>
+                          </a:solidFill>
+                        </a:rPr>
+                        <a:t>108</a:t>
+                      </a:r>
+                      <a:endParaRPr lang="en-US" sz="1200" dirty="0"/>
+                    </a:p>
+                  </a:txBody>
+                  <a:tcPr marL="91440" marR="91440" marT="45720" marB="45720">
+                    <a:lnL w="6350" cap="flat" cmpd="sng" algn="ctr">
+                      <a:solidFill>
+                        <a:srgbClr val="D0D5DD"/>
+                      </a:solidFill>
+                      <a:prstDash val="solid"/>
+                      <a:round/>
+                      <a:headEnd type="none" w="med" len="med"/>
+                      <a:tailEnd type="none" w="med" len="med"/>
+                    </a:lnL>
+                    <a:lnR w="6350" cap="flat" cmpd="sng" algn="ctr">
+                      <a:solidFill>
+                        <a:srgbClr val="D0D5DD"/>
+                      </a:solidFill>
+                      <a:prstDash val="solid"/>
+                      <a:round/>
+                      <a:headEnd type="none" w="med" len="med"/>
+                      <a:tailEnd type="none" w="med" len="med"/>
+                    </a:lnR>
+                    <a:lnT w="6350" cap="flat" cmpd="sng" algn="ctr">
+                      <a:solidFill>
+                        <a:srgbClr val="D0D5DD"/>
+                      </a:solidFill>
+                      <a:prstDash val="solid"/>
+                      <a:round/>
+                      <a:headEnd type="none" w="med" len="med"/>
+                      <a:tailEnd type="none" w="med" len="med"/>
+                    </a:lnT>
+                    <a:lnB w="6350" cap="flat" cmpd="sng" algn="ctr">
+                      <a:solidFill>
+                        <a:srgbClr val="D0D5DD"/>
+                      </a:solidFill>
+                      <a:prstDash val="solid"/>
+                      <a:round/>
+                      <a:headEnd type="none" w="med" len="med"/>
+                      <a:tailEnd type="none" w="med" len="med"/>
+                    </a:lnB>
+                  </a:tcPr>
+                </a:tc>
+                <a:tc>
+                  <a:txBody>
+                    <a:bodyPr/>
+                    <a:lstStyle/>
+                    <a:p>
+                      <a:pPr indent="0" marL="0">
+                        <a:buNone/>
+                      </a:pPr>
+                      <a:r>
+                        <a:rPr lang="en-US" sz="1200" dirty="0">
+                          <a:solidFill>
+                            <a:schemeClr val="tx1"/>
+                          </a:solidFill>
+                        </a:rPr>
+                        <a:t>44.81</a:t>
+                      </a:r>
+                      <a:endParaRPr lang="en-US" sz="1200" dirty="0"/>
+                    </a:p>
+                  </a:txBody>
+                  <a:tcPr marL="91440" marR="91440" marT="45720" marB="45720">
+                    <a:lnL w="6350" cap="flat" cmpd="sng" algn="ctr">
+                      <a:solidFill>
+                        <a:srgbClr val="D0D5DD"/>
+                      </a:solidFill>
+                      <a:prstDash val="solid"/>
+                      <a:round/>
+                      <a:headEnd type="none" w="med" len="med"/>
+                      <a:tailEnd type="none" w="med" len="med"/>
+                    </a:lnL>
+                    <a:lnR w="6350" cap="flat" cmpd="sng" algn="ctr">
+                      <a:solidFill>
+                        <a:srgbClr val="D0D5DD"/>
+                      </a:solidFill>
+                      <a:prstDash val="solid"/>
+                      <a:round/>
+                      <a:headEnd type="none" w="med" len="med"/>
+                      <a:tailEnd type="none" w="med" len="med"/>
+                    </a:lnR>
+                    <a:lnT w="6350" cap="flat" cmpd="sng" algn="ctr">
+                      <a:solidFill>
+                        <a:srgbClr val="D0D5DD"/>
+                      </a:solidFill>
+                      <a:prstDash val="solid"/>
+                      <a:round/>
+                      <a:headEnd type="none" w="med" len="med"/>
+                      <a:tailEnd type="none" w="med" len="med"/>
+                    </a:lnT>
+                    <a:lnB w="6350" cap="flat" cmpd="sng" algn="ctr">
+                      <a:solidFill>
+                        <a:srgbClr val="D0D5DD"/>
+                      </a:solidFill>
+                      <a:prstDash val="solid"/>
+                      <a:round/>
+                      <a:headEnd type="none" w="med" len="med"/>
+                      <a:tailEnd type="none" w="med" len="med"/>
+                    </a:lnB>
+                  </a:tcPr>
+                </a:tc>
+                <a:tc>
+                  <a:txBody>
+                    <a:bodyPr/>
+                    <a:lstStyle/>
+                    <a:p>
+                      <a:pPr indent="0" marL="0">
+                        <a:buNone/>
+                      </a:pPr>
+                      <a:r>
+                        <a:rPr lang="en-US" sz="1200" dirty="0">
+                          <a:solidFill>
+                            <a:schemeClr val="tx1"/>
+                          </a:solidFill>
+                        </a:rPr>
+                        <a:t>105</a:t>
+                      </a:r>
+                      <a:endParaRPr lang="en-US" sz="1200" dirty="0"/>
+                    </a:p>
+                  </a:txBody>
+                  <a:tcPr marL="91440" marR="91440" marT="45720" marB="45720">
+                    <a:lnL w="6350" cap="flat" cmpd="sng" algn="ctr">
+                      <a:solidFill>
+                        <a:srgbClr val="D0D5DD"/>
+                      </a:solidFill>
+                      <a:prstDash val="solid"/>
+                      <a:round/>
+                      <a:headEnd type="none" w="med" len="med"/>
+                      <a:tailEnd type="none" w="med" len="med"/>
+                    </a:lnL>
+                    <a:lnR w="6350" cap="flat" cmpd="sng" algn="ctr">
+                      <a:solidFill>
+                        <a:srgbClr val="D0D5DD"/>
+                      </a:solidFill>
+                      <a:prstDash val="solid"/>
+                      <a:round/>
+                      <a:headEnd type="none" w="med" len="med"/>
+                      <a:tailEnd type="none" w="med" len="med"/>
+                    </a:lnR>
+                    <a:lnT w="6350" cap="flat" cmpd="sng" algn="ctr">
+                      <a:solidFill>
+                        <a:srgbClr val="D0D5DD"/>
+                      </a:solidFill>
+                      <a:prstDash val="solid"/>
+                      <a:round/>
+                      <a:headEnd type="none" w="med" len="med"/>
+                      <a:tailEnd type="none" w="med" len="med"/>
+                    </a:lnT>
+                    <a:lnB w="6350" cap="flat" cmpd="sng" algn="ctr">
+                      <a:solidFill>
+                        <a:srgbClr val="D0D5DD"/>
+                      </a:solidFill>
+                      <a:prstDash val="solid"/>
+                      <a:round/>
+                      <a:headEnd type="none" w="med" len="med"/>
+                      <a:tailEnd type="none" w="med" len="med"/>
+                    </a:lnB>
+                  </a:tcPr>
+                </a:tc>
+                <a:tc>
+                  <a:txBody>
+                    <a:bodyPr/>
+                    <a:lstStyle/>
+                    <a:p>
+                      <a:pPr indent="0" marL="0">
+                        <a:buNone/>
+                      </a:pPr>
+                      <a:r>
+                        <a:rPr lang="en-US" sz="1200" dirty="0">
+                          <a:solidFill>
+                            <a:schemeClr val="tx1"/>
+                          </a:solidFill>
+                        </a:rPr>
+                        <a:t>43.57</a:t>
+                      </a:r>
+                      <a:endParaRPr lang="en-US" sz="1200" dirty="0"/>
+                    </a:p>
+                  </a:txBody>
+                  <a:tcPr marL="91440" marR="91440" marT="45720" marB="45720">
+                    <a:lnL w="6350" cap="flat" cmpd="sng" algn="ctr">
+                      <a:solidFill>
+                        <a:srgbClr val="D0D5DD"/>
+                      </a:solidFill>
+                      <a:prstDash val="solid"/>
+                      <a:round/>
+                      <a:headEnd type="none" w="med" len="med"/>
+                      <a:tailEnd type="none" w="med" len="med"/>
+                    </a:lnL>
+                    <a:lnR w="6350" cap="flat" cmpd="sng" algn="ctr">
+                      <a:solidFill>
+                        <a:srgbClr val="D0D5DD"/>
+                      </a:solidFill>
+                      <a:prstDash val="solid"/>
+                      <a:round/>
+                      <a:headEnd type="none" w="med" len="med"/>
+                      <a:tailEnd type="none" w="med" len="med"/>
+                    </a:lnR>
+                    <a:lnT w="6350" cap="flat" cmpd="sng" algn="ctr">
+                      <a:solidFill>
+                        <a:srgbClr val="D0D5DD"/>
+                      </a:solidFill>
+                      <a:prstDash val="solid"/>
+                      <a:round/>
+                      <a:headEnd type="none" w="med" len="med"/>
+                      <a:tailEnd type="none" w="med" len="med"/>
+                    </a:lnT>
+                    <a:lnB w="6350" cap="flat" cmpd="sng" algn="ctr">
+                      <a:solidFill>
+                        <a:srgbClr val="D0D5DD"/>
+                      </a:solidFill>
+                      <a:prstDash val="solid"/>
+                      <a:round/>
+                      <a:headEnd type="none" w="med" len="med"/>
+                      <a:tailEnd type="none" w="med" len="med"/>
+                    </a:lnB>
+                  </a:tcPr>
+                </a:tc>
+              </a:tr>
+            </a:tbl>
+          </a:graphicData>
+        </a:graphic>
+      </p:graphicFrame>
+      <p:sp>
+        <p:nvSpPr>
+          <p:cNvPr id="4" name="Text 1"/>
+          <p:cNvSpPr txBox="1"/>
           <p:nvPr/>
         </p:nvSpPr>
         <p:spPr>
           <a:xfrm>
-            <a:off x="457200" y="1005840"/>
-            <a:ext cx="4023360" cy="1600200"/>
-          </a:xfrm>
-          <a:prstGeom prst="rect">
-            <a:avLst/>
-          </a:prstGeom>
-          <a:solidFill>
-            <a:schemeClr val="bg2"/>
-          </a:solidFill>
-          <a:ln w="12700">
-            <a:solidFill>
-              <a:schemeClr val="bg2"/>
-            </a:solidFill>
-            <a:prstDash val="solid"/>
-          </a:ln>
-        </p:spPr>
-      </p:sp>
-      <p:sp>
-        <p:nvSpPr>
-          <p:cNvPr id="4" name="Text 2"/>
-          <p:cNvSpPr txBox="1"/>
-          <p:nvPr/>
-        </p:nvSpPr>
-        <p:spPr>
-          <a:xfrm>
-            <a:off x="640080" y="1170432"/>
-            <a:ext cx="365760" cy="365760"/>
-          </a:xfrm>
-          <a:prstGeom prst="rect">
-            <a:avLst/>
-          </a:prstGeom>
-          <a:noFill/>
-          <a:ln/>
-        </p:spPr>
-        <p:txBody>
-          <a:bodyPr wrap="square" lIns="0" tIns="0" rIns="0" bIns="0" rtlCol="0" anchor="ctr"/>
-          <a:lstStyle/>
-          <a:p>
-            <a:pPr indent="0" marL="0">
-              <a:buNone/>
-            </a:pPr>
-            <a:r>
-              <a:rPr lang="en-US" sz="2000" b="1" dirty="0">
-                <a:solidFill>
-                  <a:schemeClr val="accent6"/>
-                </a:solidFill>
-              </a:rPr>
-              <a:t>✓</a:t>
-            </a:r>
-            <a:endParaRPr lang="en-US" sz="2000" dirty="0"/>
-          </a:p>
-        </p:txBody>
-      </p:sp>
-      <p:sp>
-        <p:nvSpPr>
-          <p:cNvPr id="5" name="Text 3"/>
-          <p:cNvSpPr txBox="1"/>
-          <p:nvPr/>
-        </p:nvSpPr>
-        <p:spPr>
-          <a:xfrm>
-            <a:off x="1051560" y="1188720"/>
-            <a:ext cx="3291840" cy="347472"/>
-          </a:xfrm>
-          <a:prstGeom prst="rect">
-            <a:avLst/>
-          </a:prstGeom>
-          <a:noFill/>
-          <a:ln/>
-        </p:spPr>
-        <p:txBody>
-          <a:bodyPr wrap="square" lIns="0" tIns="0" rIns="0" bIns="0" rtlCol="0" anchor="ctr"/>
-          <a:lstStyle/>
-          <a:p>
-            <a:pPr indent="0" marL="0">
-              <a:buNone/>
-            </a:pPr>
-            <a:r>
-              <a:rPr lang="en-US" sz="1400" b="1" dirty="0">
-                <a:solidFill>
-                  <a:schemeClr val="tx2"/>
-                </a:solidFill>
-              </a:rPr>
-              <a:t>Person-wise folds</a:t>
-            </a:r>
-            <a:endParaRPr lang="en-US" sz="1400" dirty="0"/>
-          </a:p>
-        </p:txBody>
-      </p:sp>
-      <p:sp>
-        <p:nvSpPr>
-          <p:cNvPr id="6" name="Text 4"/>
-          <p:cNvSpPr txBox="1"/>
-          <p:nvPr/>
-        </p:nvSpPr>
-        <p:spPr>
-          <a:xfrm>
-            <a:off x="1051560" y="1572768"/>
-            <a:ext cx="3291840" cy="960120"/>
+            <a:off x="6172200" y="960120"/>
+            <a:ext cx="2514600" cy="3657600"/>
           </a:xfrm>
           <a:prstGeom prst="rect">
             <a:avLst/>
@@ -7042,417 +10018,84 @@
           <a:bodyPr wrap="square" lIns="0" tIns="0" rIns="0" bIns="0" rtlCol="0" anchor="t"/>
           <a:lstStyle/>
           <a:p>
-            <a:pPr indent="0" marL="0">
-              <a:buNone/>
+            <a:pPr marL="177800" indent="-177800">
+              <a:spcAft>
+                <a:spcPts val="600"/>
+              </a:spcAft>
+              <a:buSzPct val="100000"/>
+              <a:buChar char="•"/>
             </a:pPr>
             <a:r>
-              <a:rPr lang="en-US" sz="1300" dirty="0">
+              <a:rPr lang="en-US" sz="1150" dirty="0">
                 <a:solidFill>
                   <a:schemeClr val="tx1"/>
                 </a:solidFill>
               </a:rPr>
-              <a:t>No participant appears in both training and test sets in any fold; no duplicate EDF files.</a:t>
+              <a:t>Same 5 person-wise folds, imagery calibration and mirror augmentation for every model.</a:t>
             </a:r>
-            <a:endParaRPr lang="en-US" sz="1300" dirty="0"/>
-          </a:p>
-        </p:txBody>
-      </p:sp>
-      <p:sp>
-        <p:nvSpPr>
-          <p:cNvPr id="7" name="check Label permutation"/>
-          <p:cNvSpPr/>
-          <p:nvPr/>
-        </p:nvSpPr>
-        <p:spPr>
-          <a:xfrm>
-            <a:off x="4663440" y="1005840"/>
-            <a:ext cx="4023360" cy="1600200"/>
-          </a:xfrm>
-          <a:prstGeom prst="rect">
-            <a:avLst/>
-          </a:prstGeom>
-          <a:solidFill>
-            <a:schemeClr val="bg2"/>
-          </a:solidFill>
-          <a:ln w="12700">
-            <a:solidFill>
-              <a:schemeClr val="bg2"/>
-            </a:solidFill>
-            <a:prstDash val="solid"/>
-          </a:ln>
-        </p:spPr>
-      </p:sp>
-      <p:sp>
-        <p:nvSpPr>
-          <p:cNvPr id="8" name="Text 6"/>
-          <p:cNvSpPr txBox="1"/>
-          <p:nvPr/>
-        </p:nvSpPr>
-        <p:spPr>
-          <a:xfrm>
-            <a:off x="4846320" y="1170432"/>
-            <a:ext cx="365760" cy="365760"/>
-          </a:xfrm>
-          <a:prstGeom prst="rect">
-            <a:avLst/>
-          </a:prstGeom>
-          <a:noFill/>
-          <a:ln/>
-        </p:spPr>
-        <p:txBody>
-          <a:bodyPr wrap="square" lIns="0" tIns="0" rIns="0" bIns="0" rtlCol="0" anchor="ctr"/>
-          <a:lstStyle/>
-          <a:p>
-            <a:pPr indent="0" marL="0">
-              <a:buNone/>
+            <a:endParaRPr lang="en-US" sz="1150" dirty="0"/>
+          </a:p>
+          <a:p>
+            <a:pPr marL="177800" indent="-177800">
+              <a:spcAft>
+                <a:spcPts val="600"/>
+              </a:spcAft>
+              <a:buSzPct val="100000"/>
+              <a:buChar char="•"/>
             </a:pPr>
             <a:r>
-              <a:rPr lang="en-US" sz="2000" b="1" dirty="0">
-                <a:solidFill>
-                  <a:schemeClr val="accent6"/>
-                </a:solidFill>
-              </a:rPr>
-              <a:t>✓</a:t>
-            </a:r>
-            <a:endParaRPr lang="en-US" sz="2000" dirty="0"/>
-          </a:p>
-        </p:txBody>
-      </p:sp>
-      <p:sp>
-        <p:nvSpPr>
-          <p:cNvPr id="9" name="Text 7"/>
-          <p:cNvSpPr txBox="1"/>
-          <p:nvPr/>
-        </p:nvSpPr>
-        <p:spPr>
-          <a:xfrm>
-            <a:off x="5257800" y="1188720"/>
-            <a:ext cx="3291840" cy="347472"/>
-          </a:xfrm>
-          <a:prstGeom prst="rect">
-            <a:avLst/>
-          </a:prstGeom>
-          <a:noFill/>
-          <a:ln/>
-        </p:spPr>
-        <p:txBody>
-          <a:bodyPr wrap="square" lIns="0" tIns="0" rIns="0" bIns="0" rtlCol="0" anchor="ctr"/>
-          <a:lstStyle/>
-          <a:p>
-            <a:pPr indent="0" marL="0">
-              <a:buNone/>
-            </a:pPr>
-            <a:r>
-              <a:rPr lang="en-US" sz="1400" b="1" dirty="0">
-                <a:solidFill>
-                  <a:schemeClr val="tx2"/>
-                </a:solidFill>
-              </a:rPr>
-              <a:t>Label permutation</a:t>
-            </a:r>
-            <a:endParaRPr lang="en-US" sz="1400" dirty="0"/>
-          </a:p>
-        </p:txBody>
-      </p:sp>
-      <p:sp>
-        <p:nvSpPr>
-          <p:cNvPr id="10" name="Text 8"/>
-          <p:cNvSpPr txBox="1"/>
-          <p:nvPr/>
-        </p:nvSpPr>
-        <p:spPr>
-          <a:xfrm>
-            <a:off x="5257800" y="1572768"/>
-            <a:ext cx="3291840" cy="960120"/>
-          </a:xfrm>
-          <a:prstGeom prst="rect">
-            <a:avLst/>
-          </a:prstGeom>
-          <a:noFill/>
-          <a:ln/>
-        </p:spPr>
-        <p:txBody>
-          <a:bodyPr wrap="square" lIns="0" tIns="0" rIns="0" bIns="0" rtlCol="0" anchor="t"/>
-          <a:lstStyle/>
-          <a:p>
-            <a:pPr indent="0" marL="0">
-              <a:buNone/>
-            </a:pPr>
-            <a:r>
-              <a:rPr lang="en-US" sz="1300" dirty="0">
+              <a:rPr lang="en-US" sz="1150" dirty="0">
                 <a:solidFill>
                   <a:schemeClr val="tx1"/>
                 </a:solidFill>
               </a:rPr>
-              <a:t>With shuffled labels the pipeline falls to chance: 49.4 / 54.6 / 48.3% (binary), 18.7 / 17.6 / 18.5% (6-class).</a:t>
+              <a:t>Linear models work best: the left/right signal is a weak, roughly linear power difference between hemispheres.</a:t>
             </a:r>
-            <a:endParaRPr lang="en-US" sz="1300" dirty="0"/>
-          </a:p>
-        </p:txBody>
-      </p:sp>
-      <p:sp>
-        <p:nvSpPr>
-          <p:cNvPr id="11" name="check Reproducibility"/>
-          <p:cNvSpPr/>
-          <p:nvPr/>
-        </p:nvSpPr>
-        <p:spPr>
-          <a:xfrm>
-            <a:off x="457200" y="2788920"/>
-            <a:ext cx="4023360" cy="1600200"/>
-          </a:xfrm>
-          <a:prstGeom prst="rect">
-            <a:avLst/>
-          </a:prstGeom>
-          <a:solidFill>
-            <a:schemeClr val="bg2"/>
-          </a:solidFill>
-          <a:ln w="12700">
-            <a:solidFill>
-              <a:schemeClr val="bg2"/>
-            </a:solidFill>
-            <a:prstDash val="solid"/>
-          </a:ln>
-        </p:spPr>
-      </p:sp>
-      <p:sp>
-        <p:nvSpPr>
-          <p:cNvPr id="12" name="Text 10"/>
-          <p:cNvSpPr txBox="1"/>
-          <p:nvPr/>
-        </p:nvSpPr>
-        <p:spPr>
-          <a:xfrm>
-            <a:off x="640080" y="2953512"/>
-            <a:ext cx="365760" cy="365760"/>
-          </a:xfrm>
-          <a:prstGeom prst="rect">
-            <a:avLst/>
-          </a:prstGeom>
-          <a:noFill/>
-          <a:ln/>
-        </p:spPr>
-        <p:txBody>
-          <a:bodyPr wrap="square" lIns="0" tIns="0" rIns="0" bIns="0" rtlCol="0" anchor="ctr"/>
-          <a:lstStyle/>
-          <a:p>
-            <a:pPr indent="0" marL="0">
-              <a:buNone/>
+            <a:endParaRPr lang="en-US" sz="1150" dirty="0"/>
+          </a:p>
+          <a:p>
+            <a:pPr marL="177800" indent="-177800">
+              <a:spcAft>
+                <a:spcPts val="600"/>
+              </a:spcAft>
+              <a:buSzPct val="100000"/>
+              <a:buChar char="•"/>
             </a:pPr>
             <a:r>
-              <a:rPr lang="en-US" sz="2000" b="1" dirty="0">
-                <a:solidFill>
-                  <a:schemeClr val="accent6"/>
-                </a:solidFill>
-              </a:rPr>
-              <a:t>✓</a:t>
-            </a:r>
-            <a:endParaRPr lang="en-US" sz="2000" dirty="0"/>
-          </a:p>
-        </p:txBody>
-      </p:sp>
-      <p:sp>
-        <p:nvSpPr>
-          <p:cNvPr id="13" name="Text 11"/>
-          <p:cNvSpPr txBox="1"/>
-          <p:nvPr/>
-        </p:nvSpPr>
-        <p:spPr>
-          <a:xfrm>
-            <a:off x="1051560" y="2971800"/>
-            <a:ext cx="3291840" cy="347472"/>
-          </a:xfrm>
-          <a:prstGeom prst="rect">
-            <a:avLst/>
-          </a:prstGeom>
-          <a:noFill/>
-          <a:ln/>
-        </p:spPr>
-        <p:txBody>
-          <a:bodyPr wrap="square" lIns="0" tIns="0" rIns="0" bIns="0" rtlCol="0" anchor="ctr"/>
-          <a:lstStyle/>
-          <a:p>
-            <a:pPr indent="0" marL="0">
-              <a:buNone/>
-            </a:pPr>
-            <a:r>
-              <a:rPr lang="en-US" sz="1400" b="1" dirty="0">
-                <a:solidFill>
-                  <a:schemeClr val="tx2"/>
-                </a:solidFill>
-              </a:rPr>
-              <a:t>Reproducibility</a:t>
-            </a:r>
-            <a:endParaRPr lang="en-US" sz="1400" dirty="0"/>
-          </a:p>
-        </p:txBody>
-      </p:sp>
-      <p:sp>
-        <p:nvSpPr>
-          <p:cNvPr id="14" name="Text 12"/>
-          <p:cNvSpPr txBox="1"/>
-          <p:nvPr/>
-        </p:nvSpPr>
-        <p:spPr>
-          <a:xfrm>
-            <a:off x="1051560" y="3355848"/>
-            <a:ext cx="3291840" cy="960120"/>
-          </a:xfrm>
-          <a:prstGeom prst="rect">
-            <a:avLst/>
-          </a:prstGeom>
-          <a:noFill/>
-          <a:ln/>
-        </p:spPr>
-        <p:txBody>
-          <a:bodyPr wrap="square" lIns="0" tIns="0" rIns="0" bIns="0" rtlCol="0" anchor="t"/>
-          <a:lstStyle/>
-          <a:p>
-            <a:pPr indent="0" marL="0">
-              <a:buNone/>
-            </a:pPr>
-            <a:r>
-              <a:rPr lang="en-US" sz="1300" dirty="0">
+              <a:rPr lang="en-US" sz="1150" b="1" dirty="0">
                 <a:solidFill>
                   <a:schemeClr val="tx1"/>
                 </a:solidFill>
               </a:rPr>
-              <a:t>Same seed twice: 382 / 476 both times. Seeds 1, 2, 3: 384, 384, 386. Mean 80.59 ± 0.35%; changes come from the seed, not from learning across runs.</a:t>
+              <a:t>CSP: </a:t>
             </a:r>
-            <a:endParaRPr lang="en-US" sz="1300" dirty="0"/>
-          </a:p>
-        </p:txBody>
-      </p:sp>
-      <p:sp>
-        <p:nvSpPr>
-          <p:cNvPr id="15" name="check Onset sensitivity"/>
-          <p:cNvSpPr/>
-          <p:nvPr/>
-        </p:nvSpPr>
-        <p:spPr>
-          <a:xfrm>
-            <a:off x="4663440" y="2788920"/>
-            <a:ext cx="4023360" cy="1600200"/>
-          </a:xfrm>
-          <a:prstGeom prst="rect">
-            <a:avLst/>
-          </a:prstGeom>
-          <a:solidFill>
-            <a:schemeClr val="bg2"/>
-          </a:solidFill>
-          <a:ln w="12700">
-            <a:solidFill>
-              <a:schemeClr val="bg2"/>
-            </a:solidFill>
-            <a:prstDash val="solid"/>
-          </a:ln>
-        </p:spPr>
-      </p:sp>
-      <p:sp>
-        <p:nvSpPr>
-          <p:cNvPr id="16" name="Text 14"/>
-          <p:cNvSpPr txBox="1"/>
-          <p:nvPr/>
-        </p:nvSpPr>
-        <p:spPr>
-          <a:xfrm>
-            <a:off x="4846320" y="2953512"/>
-            <a:ext cx="365760" cy="365760"/>
-          </a:xfrm>
-          <a:prstGeom prst="rect">
-            <a:avLst/>
-          </a:prstGeom>
-          <a:noFill/>
-          <a:ln/>
-        </p:spPr>
-        <p:txBody>
-          <a:bodyPr wrap="square" lIns="0" tIns="0" rIns="0" bIns="0" rtlCol="0" anchor="ctr"/>
-          <a:lstStyle/>
-          <a:p>
-            <a:pPr indent="0" marL="0">
-              <a:buNone/>
-            </a:pPr>
             <a:r>
-              <a:rPr lang="en-US" sz="2000" b="1" dirty="0">
-                <a:solidFill>
-                  <a:schemeClr val="accent6"/>
-                </a:solidFill>
-              </a:rPr>
-              <a:t>✓</a:t>
-            </a:r>
-            <a:endParaRPr lang="en-US" sz="2000" dirty="0"/>
-          </a:p>
-        </p:txBody>
-      </p:sp>
-      <p:sp>
-        <p:nvSpPr>
-          <p:cNvPr id="17" name="Text 15"/>
-          <p:cNvSpPr txBox="1"/>
-          <p:nvPr/>
-        </p:nvSpPr>
-        <p:spPr>
-          <a:xfrm>
-            <a:off x="5257800" y="2971800"/>
-            <a:ext cx="3291840" cy="347472"/>
-          </a:xfrm>
-          <a:prstGeom prst="rect">
-            <a:avLst/>
-          </a:prstGeom>
-          <a:noFill/>
-          <a:ln/>
-        </p:spPr>
-        <p:txBody>
-          <a:bodyPr wrap="square" lIns="0" tIns="0" rIns="0" bIns="0" rtlCol="0" anchor="ctr"/>
-          <a:lstStyle/>
-          <a:p>
-            <a:pPr indent="0" marL="0">
-              <a:buNone/>
-            </a:pPr>
-            <a:r>
-              <a:rPr lang="en-US" sz="1400" b="1" dirty="0">
-                <a:solidFill>
-                  <a:schemeClr val="tx2"/>
-                </a:solidFill>
-              </a:rPr>
-              <a:t>Onset sensitivity</a:t>
-            </a:r>
-            <a:endParaRPr lang="en-US" sz="1400" dirty="0"/>
-          </a:p>
-        </p:txBody>
-      </p:sp>
-      <p:sp>
-        <p:nvSpPr>
-          <p:cNvPr id="18" name="Text 16"/>
-          <p:cNvSpPr txBox="1"/>
-          <p:nvPr/>
-        </p:nvSpPr>
-        <p:spPr>
-          <a:xfrm>
-            <a:off x="5257800" y="3355848"/>
-            <a:ext cx="3291840" cy="960120"/>
-          </a:xfrm>
-          <a:prstGeom prst="rect">
-            <a:avLst/>
-          </a:prstGeom>
-          <a:noFill/>
-          <a:ln/>
-        </p:spPr>
-        <p:txBody>
-          <a:bodyPr wrap="square" lIns="0" tIns="0" rIns="0" bIns="0" rtlCol="0" anchor="t"/>
-          <a:lstStyle/>
-          <a:p>
-            <a:pPr indent="0" marL="0">
-              <a:buNone/>
-            </a:pPr>
-            <a:r>
-              <a:rPr lang="en-US" sz="1300" dirty="0">
+              <a:rPr lang="en-US" sz="1150" dirty="0">
                 <a:solidFill>
                   <a:schemeClr val="tx1"/>
                 </a:solidFill>
               </a:rPr>
-              <a:t>Shifting the onset by ±2 s: binary 75.9–79.2%, so the reported figure may be about 3 points optimistic.</a:t>
+              <a:t>+4 trials for LR and LDA (59.34%, p = 0.002), no gain for the ensemble. The rise is within fold spread (±5%), so CSP is optional, not a clear improvement.</a:t>
             </a:r>
-            <a:endParaRPr lang="en-US" sz="1300" dirty="0"/>
+            <a:endParaRPr lang="en-US" sz="1150" dirty="0"/>
+          </a:p>
+          <a:p>
+            <a:pPr marL="177800" indent="-177800">
+              <a:spcAft>
+                <a:spcPts val="600"/>
+              </a:spcAft>
+              <a:buSzPct val="100000"/>
+              <a:buChar char="•"/>
+            </a:pPr>
+            <a:r>
+              <a:rPr lang="en-US" sz="1150" dirty="0">
+                <a:solidFill>
+                  <a:schemeClr val="tx1"/>
+                </a:solidFill>
+              </a:rPr>
+              <a:t>Trees and Naive Bayes stay near chance with 241 trials.</a:t>
+            </a:r>
+            <a:endParaRPr lang="en-US" sz="1150" dirty="0"/>
           </a:p>
         </p:txBody>
       </p:sp>
@@ -7558,6 +10201,646 @@
                   <a:schemeClr val="tx2"/>
                 </a:solidFill>
               </a:rPr>
+              <a:t>Is the accuracy real? Leakage checks</a:t>
+            </a:r>
+            <a:endParaRPr lang="en-US" sz="2400" dirty="0"/>
+          </a:p>
+        </p:txBody>
+      </p:sp>
+      <p:sp>
+        <p:nvSpPr>
+          <p:cNvPr id="3" name="check Person-wise folds"/>
+          <p:cNvSpPr/>
+          <p:nvPr/>
+        </p:nvSpPr>
+        <p:spPr>
+          <a:xfrm>
+            <a:off x="457200" y="1005840"/>
+            <a:ext cx="4023360" cy="1600200"/>
+          </a:xfrm>
+          <a:prstGeom prst="rect">
+            <a:avLst/>
+          </a:prstGeom>
+          <a:solidFill>
+            <a:schemeClr val="bg2"/>
+          </a:solidFill>
+          <a:ln w="12700">
+            <a:solidFill>
+              <a:schemeClr val="bg2"/>
+            </a:solidFill>
+            <a:prstDash val="solid"/>
+          </a:ln>
+        </p:spPr>
+      </p:sp>
+      <p:sp>
+        <p:nvSpPr>
+          <p:cNvPr id="4" name="Text 2"/>
+          <p:cNvSpPr txBox="1"/>
+          <p:nvPr/>
+        </p:nvSpPr>
+        <p:spPr>
+          <a:xfrm>
+            <a:off x="640080" y="1170432"/>
+            <a:ext cx="365760" cy="365760"/>
+          </a:xfrm>
+          <a:prstGeom prst="rect">
+            <a:avLst/>
+          </a:prstGeom>
+          <a:noFill/>
+          <a:ln/>
+        </p:spPr>
+        <p:txBody>
+          <a:bodyPr wrap="square" lIns="0" tIns="0" rIns="0" bIns="0" rtlCol="0" anchor="ctr"/>
+          <a:lstStyle/>
+          <a:p>
+            <a:pPr indent="0" marL="0">
+              <a:buNone/>
+            </a:pPr>
+            <a:r>
+              <a:rPr lang="en-US" sz="2000" b="1" dirty="0">
+                <a:solidFill>
+                  <a:schemeClr val="accent6"/>
+                </a:solidFill>
+              </a:rPr>
+              <a:t>✓</a:t>
+            </a:r>
+            <a:endParaRPr lang="en-US" sz="2000" dirty="0"/>
+          </a:p>
+        </p:txBody>
+      </p:sp>
+      <p:sp>
+        <p:nvSpPr>
+          <p:cNvPr id="5" name="Text 3"/>
+          <p:cNvSpPr txBox="1"/>
+          <p:nvPr/>
+        </p:nvSpPr>
+        <p:spPr>
+          <a:xfrm>
+            <a:off x="1051560" y="1188720"/>
+            <a:ext cx="3291840" cy="347472"/>
+          </a:xfrm>
+          <a:prstGeom prst="rect">
+            <a:avLst/>
+          </a:prstGeom>
+          <a:noFill/>
+          <a:ln/>
+        </p:spPr>
+        <p:txBody>
+          <a:bodyPr wrap="square" lIns="0" tIns="0" rIns="0" bIns="0" rtlCol="0" anchor="ctr"/>
+          <a:lstStyle/>
+          <a:p>
+            <a:pPr indent="0" marL="0">
+              <a:buNone/>
+            </a:pPr>
+            <a:r>
+              <a:rPr lang="en-US" sz="1400" b="1" dirty="0">
+                <a:solidFill>
+                  <a:schemeClr val="tx2"/>
+                </a:solidFill>
+              </a:rPr>
+              <a:t>Person-wise folds</a:t>
+            </a:r>
+            <a:endParaRPr lang="en-US" sz="1400" dirty="0"/>
+          </a:p>
+        </p:txBody>
+      </p:sp>
+      <p:sp>
+        <p:nvSpPr>
+          <p:cNvPr id="6" name="Text 4"/>
+          <p:cNvSpPr txBox="1"/>
+          <p:nvPr/>
+        </p:nvSpPr>
+        <p:spPr>
+          <a:xfrm>
+            <a:off x="1051560" y="1572768"/>
+            <a:ext cx="3291840" cy="960120"/>
+          </a:xfrm>
+          <a:prstGeom prst="rect">
+            <a:avLst/>
+          </a:prstGeom>
+          <a:noFill/>
+          <a:ln/>
+        </p:spPr>
+        <p:txBody>
+          <a:bodyPr wrap="square" lIns="0" tIns="0" rIns="0" bIns="0" rtlCol="0" anchor="t"/>
+          <a:lstStyle/>
+          <a:p>
+            <a:pPr indent="0" marL="0">
+              <a:buNone/>
+            </a:pPr>
+            <a:r>
+              <a:rPr lang="en-US" sz="1300" dirty="0">
+                <a:solidFill>
+                  <a:schemeClr val="tx1"/>
+                </a:solidFill>
+              </a:rPr>
+              <a:t>No participant appears in both training and test sets in any fold; no duplicate EDF files.</a:t>
+            </a:r>
+            <a:endParaRPr lang="en-US" sz="1300" dirty="0"/>
+          </a:p>
+        </p:txBody>
+      </p:sp>
+      <p:sp>
+        <p:nvSpPr>
+          <p:cNvPr id="7" name="check Label permutation"/>
+          <p:cNvSpPr/>
+          <p:nvPr/>
+        </p:nvSpPr>
+        <p:spPr>
+          <a:xfrm>
+            <a:off x="4663440" y="1005840"/>
+            <a:ext cx="4023360" cy="1600200"/>
+          </a:xfrm>
+          <a:prstGeom prst="rect">
+            <a:avLst/>
+          </a:prstGeom>
+          <a:solidFill>
+            <a:schemeClr val="bg2"/>
+          </a:solidFill>
+          <a:ln w="12700">
+            <a:solidFill>
+              <a:schemeClr val="bg2"/>
+            </a:solidFill>
+            <a:prstDash val="solid"/>
+          </a:ln>
+        </p:spPr>
+      </p:sp>
+      <p:sp>
+        <p:nvSpPr>
+          <p:cNvPr id="8" name="Text 6"/>
+          <p:cNvSpPr txBox="1"/>
+          <p:nvPr/>
+        </p:nvSpPr>
+        <p:spPr>
+          <a:xfrm>
+            <a:off x="4846320" y="1170432"/>
+            <a:ext cx="365760" cy="365760"/>
+          </a:xfrm>
+          <a:prstGeom prst="rect">
+            <a:avLst/>
+          </a:prstGeom>
+          <a:noFill/>
+          <a:ln/>
+        </p:spPr>
+        <p:txBody>
+          <a:bodyPr wrap="square" lIns="0" tIns="0" rIns="0" bIns="0" rtlCol="0" anchor="ctr"/>
+          <a:lstStyle/>
+          <a:p>
+            <a:pPr indent="0" marL="0">
+              <a:buNone/>
+            </a:pPr>
+            <a:r>
+              <a:rPr lang="en-US" sz="2000" b="1" dirty="0">
+                <a:solidFill>
+                  <a:schemeClr val="accent6"/>
+                </a:solidFill>
+              </a:rPr>
+              <a:t>✓</a:t>
+            </a:r>
+            <a:endParaRPr lang="en-US" sz="2000" dirty="0"/>
+          </a:p>
+        </p:txBody>
+      </p:sp>
+      <p:sp>
+        <p:nvSpPr>
+          <p:cNvPr id="9" name="Text 7"/>
+          <p:cNvSpPr txBox="1"/>
+          <p:nvPr/>
+        </p:nvSpPr>
+        <p:spPr>
+          <a:xfrm>
+            <a:off x="5257800" y="1188720"/>
+            <a:ext cx="3291840" cy="347472"/>
+          </a:xfrm>
+          <a:prstGeom prst="rect">
+            <a:avLst/>
+          </a:prstGeom>
+          <a:noFill/>
+          <a:ln/>
+        </p:spPr>
+        <p:txBody>
+          <a:bodyPr wrap="square" lIns="0" tIns="0" rIns="0" bIns="0" rtlCol="0" anchor="ctr"/>
+          <a:lstStyle/>
+          <a:p>
+            <a:pPr indent="0" marL="0">
+              <a:buNone/>
+            </a:pPr>
+            <a:r>
+              <a:rPr lang="en-US" sz="1400" b="1" dirty="0">
+                <a:solidFill>
+                  <a:schemeClr val="tx2"/>
+                </a:solidFill>
+              </a:rPr>
+              <a:t>Label permutation</a:t>
+            </a:r>
+            <a:endParaRPr lang="en-US" sz="1400" dirty="0"/>
+          </a:p>
+        </p:txBody>
+      </p:sp>
+      <p:sp>
+        <p:nvSpPr>
+          <p:cNvPr id="10" name="Text 8"/>
+          <p:cNvSpPr txBox="1"/>
+          <p:nvPr/>
+        </p:nvSpPr>
+        <p:spPr>
+          <a:xfrm>
+            <a:off x="5257800" y="1572768"/>
+            <a:ext cx="3291840" cy="960120"/>
+          </a:xfrm>
+          <a:prstGeom prst="rect">
+            <a:avLst/>
+          </a:prstGeom>
+          <a:noFill/>
+          <a:ln/>
+        </p:spPr>
+        <p:txBody>
+          <a:bodyPr wrap="square" lIns="0" tIns="0" rIns="0" bIns="0" rtlCol="0" anchor="t"/>
+          <a:lstStyle/>
+          <a:p>
+            <a:pPr indent="0" marL="0">
+              <a:buNone/>
+            </a:pPr>
+            <a:r>
+              <a:rPr lang="en-US" sz="1300" dirty="0">
+                <a:solidFill>
+                  <a:schemeClr val="tx1"/>
+                </a:solidFill>
+              </a:rPr>
+              <a:t>With shuffled labels the final pipeline falls to chance: 54.6 / 52.1 / 50.2% for action vs imagery (real labels: 80.25%).</a:t>
+            </a:r>
+            <a:endParaRPr lang="en-US" sz="1300" dirty="0"/>
+          </a:p>
+        </p:txBody>
+      </p:sp>
+      <p:sp>
+        <p:nvSpPr>
+          <p:cNvPr id="11" name="check Reproducibility"/>
+          <p:cNvSpPr/>
+          <p:nvPr/>
+        </p:nvSpPr>
+        <p:spPr>
+          <a:xfrm>
+            <a:off x="457200" y="2788920"/>
+            <a:ext cx="4023360" cy="1600200"/>
+          </a:xfrm>
+          <a:prstGeom prst="rect">
+            <a:avLst/>
+          </a:prstGeom>
+          <a:solidFill>
+            <a:schemeClr val="bg2"/>
+          </a:solidFill>
+          <a:ln w="12700">
+            <a:solidFill>
+              <a:schemeClr val="bg2"/>
+            </a:solidFill>
+            <a:prstDash val="solid"/>
+          </a:ln>
+        </p:spPr>
+      </p:sp>
+      <p:sp>
+        <p:nvSpPr>
+          <p:cNvPr id="12" name="Text 10"/>
+          <p:cNvSpPr txBox="1"/>
+          <p:nvPr/>
+        </p:nvSpPr>
+        <p:spPr>
+          <a:xfrm>
+            <a:off x="640080" y="2953512"/>
+            <a:ext cx="365760" cy="365760"/>
+          </a:xfrm>
+          <a:prstGeom prst="rect">
+            <a:avLst/>
+          </a:prstGeom>
+          <a:noFill/>
+          <a:ln/>
+        </p:spPr>
+        <p:txBody>
+          <a:bodyPr wrap="square" lIns="0" tIns="0" rIns="0" bIns="0" rtlCol="0" anchor="ctr"/>
+          <a:lstStyle/>
+          <a:p>
+            <a:pPr indent="0" marL="0">
+              <a:buNone/>
+            </a:pPr>
+            <a:r>
+              <a:rPr lang="en-US" sz="2000" b="1" dirty="0">
+                <a:solidFill>
+                  <a:schemeClr val="accent6"/>
+                </a:solidFill>
+              </a:rPr>
+              <a:t>✓</a:t>
+            </a:r>
+            <a:endParaRPr lang="en-US" sz="2000" dirty="0"/>
+          </a:p>
+        </p:txBody>
+      </p:sp>
+      <p:sp>
+        <p:nvSpPr>
+          <p:cNvPr id="13" name="Text 11"/>
+          <p:cNvSpPr txBox="1"/>
+          <p:nvPr/>
+        </p:nvSpPr>
+        <p:spPr>
+          <a:xfrm>
+            <a:off x="1051560" y="2971800"/>
+            <a:ext cx="3291840" cy="347472"/>
+          </a:xfrm>
+          <a:prstGeom prst="rect">
+            <a:avLst/>
+          </a:prstGeom>
+          <a:noFill/>
+          <a:ln/>
+        </p:spPr>
+        <p:txBody>
+          <a:bodyPr wrap="square" lIns="0" tIns="0" rIns="0" bIns="0" rtlCol="0" anchor="ctr"/>
+          <a:lstStyle/>
+          <a:p>
+            <a:pPr indent="0" marL="0">
+              <a:buNone/>
+            </a:pPr>
+            <a:r>
+              <a:rPr lang="en-US" sz="1400" b="1" dirty="0">
+                <a:solidFill>
+                  <a:schemeClr val="tx2"/>
+                </a:solidFill>
+              </a:rPr>
+              <a:t>Reproducibility</a:t>
+            </a:r>
+            <a:endParaRPr lang="en-US" sz="1400" dirty="0"/>
+          </a:p>
+        </p:txBody>
+      </p:sp>
+      <p:sp>
+        <p:nvSpPr>
+          <p:cNvPr id="14" name="Text 12"/>
+          <p:cNvSpPr txBox="1"/>
+          <p:nvPr/>
+        </p:nvSpPr>
+        <p:spPr>
+          <a:xfrm>
+            <a:off x="1051560" y="3355848"/>
+            <a:ext cx="3291840" cy="960120"/>
+          </a:xfrm>
+          <a:prstGeom prst="rect">
+            <a:avLst/>
+          </a:prstGeom>
+          <a:noFill/>
+          <a:ln/>
+        </p:spPr>
+        <p:txBody>
+          <a:bodyPr wrap="square" lIns="0" tIns="0" rIns="0" bIns="0" rtlCol="0" anchor="t"/>
+          <a:lstStyle/>
+          <a:p>
+            <a:pPr indent="0" marL="0">
+              <a:buNone/>
+            </a:pPr>
+            <a:r>
+              <a:rPr lang="en-US" sz="1300" dirty="0">
+                <a:solidFill>
+                  <a:schemeClr val="tx1"/>
+                </a:solidFill>
+              </a:rPr>
+              <a:t>Same seed twice: 382 / 476 both times. Seeds 1, 2, 3: 384, 384, 386. Mean 80.59 ± 0.35%; changes come from the seed, not from learning across runs.</a:t>
+            </a:r>
+            <a:endParaRPr lang="en-US" sz="1300" dirty="0"/>
+          </a:p>
+        </p:txBody>
+      </p:sp>
+      <p:sp>
+        <p:nvSpPr>
+          <p:cNvPr id="15" name="check Onset sensitivity"/>
+          <p:cNvSpPr/>
+          <p:nvPr/>
+        </p:nvSpPr>
+        <p:spPr>
+          <a:xfrm>
+            <a:off x="4663440" y="2788920"/>
+            <a:ext cx="4023360" cy="1600200"/>
+          </a:xfrm>
+          <a:prstGeom prst="rect">
+            <a:avLst/>
+          </a:prstGeom>
+          <a:solidFill>
+            <a:schemeClr val="bg2"/>
+          </a:solidFill>
+          <a:ln w="12700">
+            <a:solidFill>
+              <a:schemeClr val="bg2"/>
+            </a:solidFill>
+            <a:prstDash val="solid"/>
+          </a:ln>
+        </p:spPr>
+      </p:sp>
+      <p:sp>
+        <p:nvSpPr>
+          <p:cNvPr id="16" name="Text 14"/>
+          <p:cNvSpPr txBox="1"/>
+          <p:nvPr/>
+        </p:nvSpPr>
+        <p:spPr>
+          <a:xfrm>
+            <a:off x="4846320" y="2953512"/>
+            <a:ext cx="365760" cy="365760"/>
+          </a:xfrm>
+          <a:prstGeom prst="rect">
+            <a:avLst/>
+          </a:prstGeom>
+          <a:noFill/>
+          <a:ln/>
+        </p:spPr>
+        <p:txBody>
+          <a:bodyPr wrap="square" lIns="0" tIns="0" rIns="0" bIns="0" rtlCol="0" anchor="ctr"/>
+          <a:lstStyle/>
+          <a:p>
+            <a:pPr indent="0" marL="0">
+              <a:buNone/>
+            </a:pPr>
+            <a:r>
+              <a:rPr lang="en-US" sz="2000" b="1" dirty="0">
+                <a:solidFill>
+                  <a:schemeClr val="accent6"/>
+                </a:solidFill>
+              </a:rPr>
+              <a:t>✓</a:t>
+            </a:r>
+            <a:endParaRPr lang="en-US" sz="2000" dirty="0"/>
+          </a:p>
+        </p:txBody>
+      </p:sp>
+      <p:sp>
+        <p:nvSpPr>
+          <p:cNvPr id="17" name="Text 15"/>
+          <p:cNvSpPr txBox="1"/>
+          <p:nvPr/>
+        </p:nvSpPr>
+        <p:spPr>
+          <a:xfrm>
+            <a:off x="5257800" y="2971800"/>
+            <a:ext cx="3291840" cy="347472"/>
+          </a:xfrm>
+          <a:prstGeom prst="rect">
+            <a:avLst/>
+          </a:prstGeom>
+          <a:noFill/>
+          <a:ln/>
+        </p:spPr>
+        <p:txBody>
+          <a:bodyPr wrap="square" lIns="0" tIns="0" rIns="0" bIns="0" rtlCol="0" anchor="ctr"/>
+          <a:lstStyle/>
+          <a:p>
+            <a:pPr indent="0" marL="0">
+              <a:buNone/>
+            </a:pPr>
+            <a:r>
+              <a:rPr lang="en-US" sz="1400" b="1" dirty="0">
+                <a:solidFill>
+                  <a:schemeClr val="tx2"/>
+                </a:solidFill>
+              </a:rPr>
+              <a:t>Onset sensitivity</a:t>
+            </a:r>
+            <a:endParaRPr lang="en-US" sz="1400" dirty="0"/>
+          </a:p>
+        </p:txBody>
+      </p:sp>
+      <p:sp>
+        <p:nvSpPr>
+          <p:cNvPr id="18" name="Text 16"/>
+          <p:cNvSpPr txBox="1"/>
+          <p:nvPr/>
+        </p:nvSpPr>
+        <p:spPr>
+          <a:xfrm>
+            <a:off x="5257800" y="3355848"/>
+            <a:ext cx="3291840" cy="960120"/>
+          </a:xfrm>
+          <a:prstGeom prst="rect">
+            <a:avLst/>
+          </a:prstGeom>
+          <a:noFill/>
+          <a:ln/>
+        </p:spPr>
+        <p:txBody>
+          <a:bodyPr wrap="square" lIns="0" tIns="0" rIns="0" bIns="0" rtlCol="0" anchor="t"/>
+          <a:lstStyle/>
+          <a:p>
+            <a:pPr indent="0" marL="0">
+              <a:buNone/>
+            </a:pPr>
+            <a:r>
+              <a:rPr lang="en-US" sz="1300" dirty="0">
+                <a:solidFill>
+                  <a:schemeClr val="tx1"/>
+                </a:solidFill>
+              </a:rPr>
+              <a:t>Shifting the onset by ±2 s: binary 75.9–79.2%, so the reported figure may be about 3 points optimistic.</a:t>
+            </a:r>
+            <a:endParaRPr lang="en-US" sz="1300" dirty="0"/>
+          </a:p>
+        </p:txBody>
+      </p:sp>
+      <p:sp>
+        <p:nvSpPr>
+          <p:cNvPr id="25" name="Slide Number Placeholder 0"/>
+          <p:cNvSpPr>
+            <a:spLocks noGrp="1"/>
+          </p:cNvSpPr>
+          <p:nvPr>
+            <p:ph type="sldNum" sz="quarter" idx="4294967295"/>
+          </p:nvPr>
+        </p:nvSpPr>
+        <p:spPr>
+          <a:xfrm>
+            <a:off x="8229600" y="4773168"/>
+            <a:ext cx="457200" cy="228600"/>
+          </a:xfrm>
+          <a:prstGeom prst="rect">
+            <a:avLst/>
+          </a:prstGeom>
+          <a:extLst>
+            <a:ext uri="{C572A759-6A51-4108-AA02-DFA0A04FC94B}">
+              <ma14:wrappingTextBoxFlag xmlns:ma14="http://schemas.microsoft.com/office/mac/drawingml/2011/main" val="0"/>
+            </a:ext>
+          </a:extLst>
+        </p:spPr>
+        <p:txBody>
+          <a:bodyPr lIns="0" tIns="0" rIns="0" bIns="0"/>
+          <a:lstStyle>
+            <a:lvl1pPr>
+              <a:defRPr sz="900">
+                <a:solidFill>
+                  <a:schemeClr val="accent4"/>
+                </a:solidFill>
+              </a:defRPr>
+            </a:lvl1pPr>
+          </a:lstStyle>
+          <a:p>
+            <a:pPr algn="r"/>
+            <a:fld id="{F7021451-1387-4CA6-816F-3879F97B5CBC}" type="slidenum">
+              <a:rPr b="0" lang="en-US"/>
+              <a:t>15</a:t>
+            </a:fld>
+            <a:endParaRPr lang="en-US"/>
+          </a:p>
+        </p:txBody>
+      </p:sp>
+    </p:spTree>
+  </p:cSld>
+  <p:clrMapOvr>
+    <a:masterClrMapping/>
+  </p:clrMapOvr>
+</p:sld>
+</file>
+
+<file path=ppt/slides/slide16.xml><?xml version="1.0" encoding="utf-8"?>
+<p:sld xmlns:a="http://schemas.openxmlformats.org/drawingml/2006/main" xmlns:r="http://schemas.openxmlformats.org/officeDocument/2006/relationships" xmlns:p="http://schemas.openxmlformats.org/presentationml/2006/main">
+  <p:cSld name="Slide 16">
+    <p:spTree>
+      <p:nvGrpSpPr>
+        <p:cNvPr id="1" name=""/>
+        <p:cNvGrpSpPr/>
+        <p:nvPr/>
+      </p:nvGrpSpPr>
+      <p:grpSpPr>
+        <a:xfrm>
+          <a:off x="0" y="0"/>
+          <a:ext cx="0" cy="0"/>
+          <a:chOff x="0" y="0"/>
+          <a:chExt cx="0" cy="0"/>
+        </a:xfrm>
+      </p:grpSpPr>
+      <p:sp>
+        <p:nvSpPr>
+          <p:cNvPr id="2" name="Text 0"/>
+          <p:cNvSpPr/>
+          <p:nvPr>
+            <p:ph idx="100" type="title" hasCustomPrompt="1"/>
+          </p:nvPr>
+        </p:nvSpPr>
+        <p:spPr>
+          <a:xfrm>
+            <a:off x="457200" y="274320"/>
+            <a:ext cx="8229600" cy="548640"/>
+          </a:xfrm>
+          <a:prstGeom prst="rect">
+            <a:avLst/>
+          </a:prstGeom>
+          <a:noFill/>
+          <a:ln/>
+        </p:spPr>
+        <p:txBody>
+          <a:bodyPr wrap="square" lIns="0" tIns="0" rIns="0" bIns="0" rtlCol="0" anchor="ctr"/>
+          <a:lstStyle/>
+          <a:p>
+            <a:pPr algn="l" indent="0" marL="0">
+              <a:buNone/>
+            </a:pPr>
+            <a:r>
+              <a:rPr lang="en-US" sz="2400" b="1" dirty="0">
+                <a:solidFill>
+                  <a:schemeClr val="tx2"/>
+                </a:solidFill>
+              </a:rPr>
               <a:t>Response to review feedback</a:t>
             </a:r>
             <a:endParaRPr lang="en-US" sz="2400" dirty="0"/>
@@ -7566,7 +10849,7 @@
       </p:sp>
       <p:graphicFrame>
         <p:nvGraphicFramePr>
-          <p:cNvPr id="16" name="Table 0"/>
+          <p:cNvPr id="17" name="Table 0"/>
           <p:cNvGraphicFramePr>
             <a:graphicFrameLocks noGrp="1"/>
           </p:cNvGraphicFramePr>
@@ -8023,7 +11306,7 @@
                             <a:schemeClr val="tx1"/>
                           </a:solidFill>
                         </a:rPr>
-                        <a:t>All eight models (LR, LDA, SVM, RF, ET, HGB, AdaBoost, NB) and the ensemble are being run on the L/R task with the same folds.</a:t>
+                        <a:t>Done. The reported 58.09% is the ensemble. All 8 models were run on the same folds: LR 57.68%, LDA 56.85%, SVM 54.36%; tree models and NB 45–51%.</a:t>
                       </a:r>
                       <a:endParaRPr lang="en-US" sz="1200" dirty="0"/>
                     </a:p>
@@ -8141,7 +11424,7 @@
                             <a:schemeClr val="tx1"/>
                           </a:solidFill>
                         </a:rPr>
-                        <a:t>FBCSP alone is weaker (61.60% vs 64.45%; L/R 52.70% vs 58.09%). Each model is being re-run with and without FBCSP features; CSP is kept only where it helps.</a:t>
+                        <a:t>L/R done: CSP adds 4 trials for LR and LDA (59.34%) but not for the ensemble; gain is within fold noise. CSP alone is weaker (52.70%). Other tasks still running.</a:t>
                       </a:r>
                       <a:endParaRPr lang="en-US" sz="1200" dirty="0"/>
                     </a:p>
@@ -8229,7 +11512,7 @@
             <a:pPr algn="r"/>
             <a:fld id="{F7021451-1387-4CA6-816F-3879F97B5CBC}" type="slidenum">
               <a:rPr b="0" lang="en-US"/>
-              <a:t>15</a:t>
+              <a:t>16</a:t>
             </a:fld>
             <a:endParaRPr lang="en-US"/>
           </a:p>
@@ -8243,9 +11526,9 @@
 </p:sld>
 </file>
 
-<file path=ppt/slides/slide16.xml><?xml version="1.0" encoding="utf-8"?>
+<file path=ppt/slides/slide17.xml><?xml version="1.0" encoding="utf-8"?>
 <p:sld xmlns:a="http://schemas.openxmlformats.org/drawingml/2006/main" xmlns:r="http://schemas.openxmlformats.org/officeDocument/2006/relationships" xmlns:p="http://schemas.openxmlformats.org/presentationml/2006/main">
-  <p:cSld name="Slide 16">
+  <p:cSld name="Slide 17">
     <p:spTree>
       <p:nvGrpSpPr>
         <p:cNvPr id="1" name=""/>
@@ -8620,7 +11903,7 @@
             <a:pPr algn="r"/>
             <a:fld id="{F7021451-1387-4CA6-816F-3879F97B5CBC}" type="slidenum">
               <a:rPr b="0" lang="en-US"/>
-              <a:t>16</a:t>
+              <a:t>17</a:t>
             </a:fld>
             <a:endParaRPr lang="en-US"/>
           </a:p>
@@ -8634,9 +11917,9 @@
 </p:sld>
 </file>
 
-<file path=ppt/slides/slide17.xml><?xml version="1.0" encoding="utf-8"?>
+<file path=ppt/slides/slide18.xml><?xml version="1.0" encoding="utf-8"?>
 <p:sld xmlns:a="http://schemas.openxmlformats.org/drawingml/2006/main" xmlns:r="http://schemas.openxmlformats.org/officeDocument/2006/relationships" xmlns:p="http://schemas.openxmlformats.org/presentationml/2006/main">
-  <p:cSld name="Slide 17">
+  <p:cSld name="Slide 18">
     <p:spTree>
       <p:nvGrpSpPr>
         <p:cNvPr id="1" name=""/>

</xml_diff>

<commit_message>
Add 12-class permutation result; update deck
Co-Authored-By: Claude Opus 5.5 <noreply@anthropic.com>
Claude-Session: https://claude.ai/code/session_015MxpDjobAG7agz1rRFFe5k
</commit_message>
<xml_diff>
--- a/presentation/BCI_Group18_Review.pptx
+++ b/presentation/BCI_Group18_Review.pptx
@@ -125,13 +125,13 @@
   <p:extLst>
     <p:ext uri="{521415D9-36F7-43E2-AB2F-B90AF26B5E84}">
       <p14:sectionLst xmlns:p14="http://schemas.microsoft.com/office/powerpoint/2010/main">
-        <p14:section name="Introduction" id="{3f369838-cf6a-f455-91f6-265619f172de}">
+        <p14:section name="Introduction" id="{9b870863-a7da-ae39-5dfb-08e838c251bd}">
           <p14:sldIdLst>
             <p14:sldId id="256"/>
             <p14:sldId id="257"/>
           </p14:sldIdLst>
         </p14:section>
-        <p14:section name="Data and method" id="{1bce1748-4a48-3e7d-9630-a80927b2cf40}">
+        <p14:section name="Data and method" id="{6c05a138-b309-3850-ea26-d8a696833de5}">
           <p14:sldIdLst>
             <p14:sldId id="258"/>
             <p14:sldId id="259"/>
@@ -142,7 +142,7 @@
             <p14:sldId id="264"/>
           </p14:sldIdLst>
         </p14:section>
-        <p14:section name="Results" id="{0196c7cd-226c-ca34-0759-56a8786bbbff}">
+        <p14:section name="Results" id="{f51c3166-79d2-bb57-d83f-23501e46c742}">
           <p14:sldIdLst>
             <p14:sldId id="265"/>
             <p14:sldId id="266"/>
@@ -152,13 +152,13 @@
             <p14:sldId id="270"/>
           </p14:sldIdLst>
         </p14:section>
-        <p14:section name="Validity" id="{125e6c30-7afe-016a-4bca-b2c6165d915f}">
+        <p14:section name="Validity" id="{3a4bf430-fd11-81b7-ef6d-b2391098e925}">
           <p14:sldIdLst>
             <p14:sldId id="271"/>
             <p14:sldId id="272"/>
           </p14:sldIdLst>
         </p14:section>
-        <p14:section name="Conclusion" id="{e21598c1-c916-1eca-f2fb-063554486dbc}">
+        <p14:section name="Conclusion" id="{a22c62e1-6f25-d56f-4d3f-a02e4536384c}">
           <p14:sldIdLst>
             <p14:sldId id="273"/>
             <p14:sldId id="274"/>
@@ -14337,7 +14337,7 @@
                   <a:schemeClr val="tx1"/>
                 </a:solidFill>
               </a:rPr>
-              <a:t>Shuffled labels give chance: action/imagery 50–55% (real 80.25), body part 17–19% (real 26.68), left/right 44–51% (real 58.09).</a:t>
+              <a:t>Shuffled labels give chance on all tasks: action/imagery 50–55% (real 80.25), body part 17–19% (26.68), 12-class 8–11% (21.43), left/right 44–51% (58.09).</a:t>
             </a:r>
             <a:endParaRPr lang="en-US" sz="1300" dirty="0"/>
           </a:p>
@@ -15058,7 +15058,7 @@
                             <a:schemeClr val="tx1"/>
                           </a:solidFill>
                         </a:rPr>
-                        <a:t>No. Same seed gives identical results (382/476 twice); other seeds give 384–386 (80.59 ± 0.35% over 5 runs); shuffled-label tests give chance on action/imagery, body part and left/right; folds are split by person. Nested CV still running.</a:t>
+                        <a:t>No. Same seed gives identical results (382/476 twice); other seeds give 384–386 (80.59 ± 0.35% over 5 runs); shuffled-label tests give chance on all four tasks; folds are split by person. Nested CV still running.</a:t>
                       </a:r>
                       <a:endParaRPr lang="en-US" sz="1200" dirty="0"/>
                     </a:p>

</xml_diff>

<commit_message>
Nested CV for left vs right imagery (52.28%); mark 58.09% as optimistic in deck
Co-Authored-By: Claude Opus 5.5 <noreply@anthropic.com>
Claude-Session: https://claude.ai/code/session_015MxpDjobAG7agz1rRFFe5k
</commit_message>
<xml_diff>
--- a/presentation/BCI_Group18_Review.pptx
+++ b/presentation/BCI_Group18_Review.pptx
@@ -125,13 +125,13 @@
   <p:extLst>
     <p:ext uri="{521415D9-36F7-43E2-AB2F-B90AF26B5E84}">
       <p14:sectionLst xmlns:p14="http://schemas.microsoft.com/office/powerpoint/2010/main">
-        <p14:section name="Introduction" id="{9b870863-a7da-ae39-5dfb-08e838c251bd}">
+        <p14:section name="Introduction" id="{e990b9ba-b6a6-3d53-e23c-fe1125d00de8}">
           <p14:sldIdLst>
             <p14:sldId id="256"/>
             <p14:sldId id="257"/>
           </p14:sldIdLst>
         </p14:section>
-        <p14:section name="Data and method" id="{6c05a138-b309-3850-ea26-d8a696833de5}">
+        <p14:section name="Data and method" id="{79eddac0-1953-aa52-402e-14b0bfb557e7}">
           <p14:sldIdLst>
             <p14:sldId id="258"/>
             <p14:sldId id="259"/>
@@ -142,7 +142,7 @@
             <p14:sldId id="264"/>
           </p14:sldIdLst>
         </p14:section>
-        <p14:section name="Results" id="{f51c3166-79d2-bb57-d83f-23501e46c742}">
+        <p14:section name="Results" id="{3634f54c-1508-e33b-f5d0-d19ac57e0b40}">
           <p14:sldIdLst>
             <p14:sldId id="265"/>
             <p14:sldId id="266"/>
@@ -152,13 +152,13 @@
             <p14:sldId id="270"/>
           </p14:sldIdLst>
         </p14:section>
-        <p14:section name="Validity" id="{3a4bf430-fd11-81b7-ef6d-b2391098e925}">
+        <p14:section name="Validity" id="{6874d194-cd4d-a238-a68a-d786856cdb1f}">
           <p14:sldIdLst>
             <p14:sldId id="271"/>
             <p14:sldId id="272"/>
           </p14:sldIdLst>
         </p14:section>
-        <p14:section name="Conclusion" id="{a22c62e1-6f25-d56f-4d3f-a02e4536384c}">
+        <p14:section name="Conclusion" id="{91e5ce87-0498-ab89-2eef-99c11366fe20}">
           <p14:sldIdLst>
             <p14:sldId id="273"/>
             <p14:sldId id="274"/>
@@ -3866,7 +3866,7 @@
                   <a:schemeClr val="accent4"/>
                 </a:solidFill>
               </a:rPr>
-              <a:t>140 / 241 trials</a:t>
+              <a:t>140 / 241 trials, chance 50%</a:t>
             </a:r>
             <a:endParaRPr lang="en-US" sz="1100" dirty="0"/>
           </a:p>
@@ -3880,7 +3880,7 @@
                   <a:schemeClr val="accent4"/>
                 </a:solidFill>
               </a:rPr>
-              <a:t>chance 50%, p = 0.007</a:t>
+              <a:t>strict nested CV: 52.28%</a:t>
             </a:r>
             <a:endParaRPr lang="en-US" sz="1100" dirty="0"/>
           </a:p>
@@ -3920,7 +3920,7 @@
                   <a:schemeClr val="tx1"/>
                 </a:solidFill>
               </a:rPr>
-              <a:t>Trial-level accuracy, pooled over all test folds. Fold mean ± SD: 80.19 ± 6.59 (binary), 26.68 ± 1.79 (6-class), 21.42 ± 1.21 (12-class).</a:t>
+              <a:t>Trial-level accuracy, pooled over all test folds. Left vs right is not yet reliable (nested CV 52.28%). Fold mean ± SD: 80.19 ± 6.59 (binary), 26.68 ± 1.79 (6-class), 21.42 ± 1.21 (12-class).</a:t>
             </a:r>
             <a:endParaRPr lang="en-US" sz="1250" dirty="0"/>
           </a:p>
@@ -6985,12 +6985,20 @@
               <a:buChar char="•"/>
             </a:pPr>
             <a:r>
+              <a:rPr lang="en-US" sz="1250" b="1" dirty="0">
+                <a:solidFill>
+                  <a:schemeClr val="accent3"/>
+                </a:solidFill>
+              </a:rPr>
+              <a:t>Caution: </a:t>
+            </a:r>
+            <a:r>
               <a:rPr lang="en-US" sz="1250" dirty="0">
                 <a:solidFill>
                   <a:schemeClr val="tx1"/>
                 </a:solidFill>
               </a:rPr>
-              <a:t>Overall 58.09% is significant (p = 0.007); arm imagery reaches 74.07%.</a:t>
+              <a:t>strict nested CV gives 52.28% (126/241, p = 0.26). The 58.09% depends on choices made after seeing results, so it is optimistic.</a:t>
             </a:r>
             <a:endParaRPr lang="en-US" sz="1250" dirty="0"/>
           </a:p>
@@ -15058,7 +15066,7 @@
                             <a:schemeClr val="tx1"/>
                           </a:solidFill>
                         </a:rPr>
-                        <a:t>No. Same seed gives identical results (382/476 twice); other seeds give 384–386 (80.59 ± 0.35% over 5 runs); shuffled-label tests give chance on all four tasks; folds are split by person. Nested CV still running.</a:t>
+                        <a:t>No. Same seed gives identical results (382/476 twice); other seeds give 384–386 (80.59 ± 0.35% over 5 runs); shuffled-label tests give chance on all four tasks; folds are split by person. Nested CV on left vs right: 52.28%, so that result was optimistic.</a:t>
                       </a:r>
                       <a:endParaRPr lang="en-US" sz="1200" dirty="0"/>
                     </a:p>
@@ -15558,6 +15566,24 @@
                 </a:solidFill>
               </a:rPr>
               <a:t>One session per person: no cross-session tests.</a:t>
+            </a:r>
+            <a:endParaRPr lang="en-US" sz="1300" dirty="0"/>
+          </a:p>
+          <a:p>
+            <a:pPr marL="177800" indent="-177800">
+              <a:spcAft>
+                <a:spcPts val="600"/>
+              </a:spcAft>
+              <a:buSzPct val="100000"/>
+              <a:buChar char="•"/>
+            </a:pPr>
+            <a:r>
+              <a:rPr lang="en-US" sz="1300" dirty="0">
+                <a:solidFill>
+                  <a:schemeClr val="tx1"/>
+                </a:solidFill>
+              </a:rPr>
+              <a:t>Left vs right imagery is not yet reliable: 52.28% under nested CV.</a:t>
             </a:r>
             <a:endParaRPr lang="en-US" sz="1300" dirty="0"/>
           </a:p>
@@ -15874,7 +15900,7 @@
                   <a:schemeClr val="accent5"/>
                 </a:solidFill>
               </a:rPr>
-              <a:t>Action vs imagery 80.25%  ·  Left vs right imagery 58.09%  ·  person-wise validation</a:t>
+              <a:t>Action vs imagery 80.25%  ·  person-wise validation  ·  leakage checks passed</a:t>
             </a:r>
             <a:endParaRPr lang="en-US" sz="1400" dirty="0"/>
           </a:p>

</xml_diff>